<commit_message>
Golden renders refreshed after the three fixes
Rebuilt the five reference decks with aa30cf4 and re-exported every slide
(now 102: Reference B gains a three-cell and a four-cell formula triangle).
The first set stays in history at e0d5210 for before-and-after comparison.

design-inventory.md and render-constraints.md now describe the fixed
behaviour, and list two issues seen in the renders but left alone: a long
mark scheme can overflow its panel, and "kg/m^3" prints raw in GUESS rows.
CHANGELOG.md records the session.

Co-Authored-By: Claude Opus 5.5 <noreply@anthropic.com>
</commit_message>
<xml_diff>
--- a/science-lesson-v4/golden/build/Reference-C-Marking-Slides.pptx
+++ b/science-lesson-v4/golden/build/Reference-C-Marking-Slides.pptx
@@ -3792,22 +3792,41 @@
           </a:p>
         </p:txBody>
       </p:sp>
+      <p:sp>
+        <p:nvSpPr>
+          <p:cNvPr id="11" name="Shape 9"/>
+          <p:cNvSpPr/>
+          <p:nvPr/>
+        </p:nvSpPr>
+        <p:spPr>
+          <a:xfrm>
+            <a:off x="411480" y="1472184"/>
+            <a:ext cx="5637276" cy="1274308"/>
+          </a:xfrm>
+          <a:prstGeom prst="rect">
+            <a:avLst/>
+          </a:prstGeom>
+          <a:solidFill>
+            <a:srgbClr val="FFFFFF"/>
+          </a:solidFill>
+          <a:ln w="25400">
+            <a:solidFill>
+              <a:srgbClr val="FABB2E"/>
+            </a:solidFill>
+            <a:prstDash val="solid"/>
+          </a:ln>
+        </p:spPr>
+      </p:sp>
       <p:pic>
         <p:nvPicPr>
-          <p:cNvPr id="11" name="Image 0" descr="C:\Users\magda\AppData\Local\Temp\hw_1788477041208_kjibywkvpv.svg">    </p:cNvPr>
+          <p:cNvPr id="12" name="Image 0" descr="C:\Users\magda\AppData\Local\Temp\hw_out_1790976054384_rn2mci2a8vi.png">    </p:cNvPr>
           <p:cNvPicPr>
             <a:picLocks noChangeAspect="1"/>
           </p:cNvPicPr>
           <p:nvPr/>
         </p:nvPicPr>
         <p:blipFill>
-          <a:blip r:embed="rId1">
-            <a:extLst>
-              <a:ext uri="{96DAC541-7B7A-43D3-8B79-37D633B846F1}">
-                <asvg:svgBlip xmlns:asvg="http://schemas.microsoft.com/office/drawing/2016/SVG/main" r:embed="rId2"/>
-              </a:ext>
-            </a:extLst>
-          </a:blip>
+          <a:blip r:embed="rId1"/>
           <a:stretch>
             <a:fillRect/>
           </a:stretch>
@@ -3824,7 +3843,7 @@
       </p:pic>
       <p:sp>
         <p:nvSpPr>
-          <p:cNvPr id="12" name="Text 9"/>
+          <p:cNvPr id="13" name="Text 10"/>
           <p:cNvSpPr/>
           <p:nvPr/>
         </p:nvSpPr>
@@ -3883,22 +3902,41 @@
           </a:p>
         </p:txBody>
       </p:sp>
+      <p:sp>
+        <p:nvSpPr>
+          <p:cNvPr id="14" name="Shape 11"/>
+          <p:cNvSpPr/>
+          <p:nvPr/>
+        </p:nvSpPr>
+        <p:spPr>
+          <a:xfrm>
+            <a:off x="6140196" y="1472184"/>
+            <a:ext cx="5637276" cy="1274308"/>
+          </a:xfrm>
+          <a:prstGeom prst="rect">
+            <a:avLst/>
+          </a:prstGeom>
+          <a:solidFill>
+            <a:srgbClr val="FFFFFF"/>
+          </a:solidFill>
+          <a:ln w="25400">
+            <a:solidFill>
+              <a:srgbClr val="FABB2E"/>
+            </a:solidFill>
+            <a:prstDash val="solid"/>
+          </a:ln>
+        </p:spPr>
+      </p:sp>
       <p:pic>
         <p:nvPicPr>
-          <p:cNvPr id="13" name="Image 1" descr="C:\Users\magda\AppData\Local\Temp\hw_1788477041321_bslhnd5n6u6.svg">    </p:cNvPr>
+          <p:cNvPr id="15" name="Image 1" descr="C:\Users\magda\AppData\Local\Temp\hw_out_1790976056413_rdrrqrrmoo.png">    </p:cNvPr>
           <p:cNvPicPr>
             <a:picLocks noChangeAspect="1"/>
           </p:cNvPicPr>
           <p:nvPr/>
         </p:nvPicPr>
         <p:blipFill>
-          <a:blip r:embed="rId3">
-            <a:extLst>
-              <a:ext uri="{96DAC541-7B7A-43D3-8B79-37D633B846F1}">
-                <asvg:svgBlip xmlns:asvg="http://schemas.microsoft.com/office/drawing/2016/SVG/main" r:embed="rId4"/>
-              </a:ext>
-            </a:extLst>
-          </a:blip>
+          <a:blip r:embed="rId2"/>
           <a:stretch>
             <a:fillRect/>
           </a:stretch>
@@ -3915,7 +3953,7 @@
       </p:pic>
       <p:sp>
         <p:nvSpPr>
-          <p:cNvPr id="14" name="Text 10"/>
+          <p:cNvPr id="16" name="Text 12"/>
           <p:cNvSpPr/>
           <p:nvPr/>
         </p:nvSpPr>
@@ -3974,22 +4012,41 @@
           </a:p>
         </p:txBody>
       </p:sp>
+      <p:sp>
+        <p:nvSpPr>
+          <p:cNvPr id="17" name="Shape 13"/>
+          <p:cNvSpPr/>
+          <p:nvPr/>
+        </p:nvSpPr>
+        <p:spPr>
+          <a:xfrm>
+            <a:off x="411480" y="4014216"/>
+            <a:ext cx="5637276" cy="1274308"/>
+          </a:xfrm>
+          <a:prstGeom prst="rect">
+            <a:avLst/>
+          </a:prstGeom>
+          <a:solidFill>
+            <a:srgbClr val="FFFFFF"/>
+          </a:solidFill>
+          <a:ln w="25400">
+            <a:solidFill>
+              <a:srgbClr val="FABB2E"/>
+            </a:solidFill>
+            <a:prstDash val="solid"/>
+          </a:ln>
+        </p:spPr>
+      </p:sp>
       <p:pic>
         <p:nvPicPr>
-          <p:cNvPr id="15" name="Image 2" descr="C:\Users\magda\AppData\Local\Temp\hw_1788477041585_ziw3u97rsfj.svg">    </p:cNvPr>
+          <p:cNvPr id="18" name="Image 2" descr="C:\Users\magda\AppData\Local\Temp\hw_out_1790976057471_njsdrg076d.png">    </p:cNvPr>
           <p:cNvPicPr>
             <a:picLocks noChangeAspect="1"/>
           </p:cNvPicPr>
           <p:nvPr/>
         </p:nvPicPr>
         <p:blipFill>
-          <a:blip r:embed="rId5">
-            <a:extLst>
-              <a:ext uri="{96DAC541-7B7A-43D3-8B79-37D633B846F1}">
-                <asvg:svgBlip xmlns:asvg="http://schemas.microsoft.com/office/drawing/2016/SVG/main" r:embed="rId6"/>
-              </a:ext>
-            </a:extLst>
-          </a:blip>
+          <a:blip r:embed="rId3"/>
           <a:stretch>
             <a:fillRect/>
           </a:stretch>
@@ -4006,7 +4063,7 @@
       </p:pic>
       <p:sp>
         <p:nvSpPr>
-          <p:cNvPr id="16" name="Text 11"/>
+          <p:cNvPr id="19" name="Text 14"/>
           <p:cNvSpPr/>
           <p:nvPr/>
         </p:nvSpPr>
@@ -4065,22 +4122,41 @@
           </a:p>
         </p:txBody>
       </p:sp>
+      <p:sp>
+        <p:nvSpPr>
+          <p:cNvPr id="20" name="Shape 15"/>
+          <p:cNvSpPr/>
+          <p:nvPr/>
+        </p:nvSpPr>
+        <p:spPr>
+          <a:xfrm>
+            <a:off x="6140196" y="4014216"/>
+            <a:ext cx="5637276" cy="1274308"/>
+          </a:xfrm>
+          <a:prstGeom prst="rect">
+            <a:avLst/>
+          </a:prstGeom>
+          <a:solidFill>
+            <a:srgbClr val="FFFFFF"/>
+          </a:solidFill>
+          <a:ln w="25400">
+            <a:solidFill>
+              <a:srgbClr val="FABB2E"/>
+            </a:solidFill>
+            <a:prstDash val="solid"/>
+          </a:ln>
+        </p:spPr>
+      </p:sp>
       <p:pic>
         <p:nvPicPr>
-          <p:cNvPr id="17" name="Image 3" descr="C:\Users\magda\AppData\Local\Temp\hw_1788477041589_6yur7dmbsdi.svg">    </p:cNvPr>
+          <p:cNvPr id="21" name="Image 3" descr="C:\Users\magda\AppData\Local\Temp\hw_out_1790976058297_26y53120s6b.png">    </p:cNvPr>
           <p:cNvPicPr>
             <a:picLocks noChangeAspect="1"/>
           </p:cNvPicPr>
           <p:nvPr/>
         </p:nvPicPr>
         <p:blipFill>
-          <a:blip r:embed="rId7">
-            <a:extLst>
-              <a:ext uri="{96DAC541-7B7A-43D3-8B79-37D633B846F1}">
-                <asvg:svgBlip xmlns:asvg="http://schemas.microsoft.com/office/drawing/2016/SVG/main" r:embed="rId8"/>
-              </a:ext>
-            </a:extLst>
-          </a:blip>
+          <a:blip r:embed="rId4"/>
           <a:stretch>
             <a:fillRect/>
           </a:stretch>
@@ -4097,7 +4173,7 @@
       </p:pic>
       <p:sp>
         <p:nvSpPr>
-          <p:cNvPr id="18" name="Text 12"/>
+          <p:cNvPr id="22" name="Text 16"/>
           <p:cNvSpPr/>
           <p:nvPr/>
         </p:nvSpPr>
@@ -4158,7 +4234,7 @@
       </p:sp>
       <p:sp>
         <p:nvSpPr>
-          <p:cNvPr id="19" name="Text 13"/>
+          <p:cNvPr id="23" name="Text 17"/>
           <p:cNvSpPr/>
           <p:nvPr/>
         </p:nvSpPr>
@@ -5686,7 +5762,7 @@
       </p:graphicFrame>
       <p:pic>
         <p:nvPicPr>
-          <p:cNvPr id="11" name="Image 0" descr="C:\Users\magda\AppData\Local\Temp\gg_out_1788477041684.png">    </p:cNvPr>
+          <p:cNvPr id="11" name="Image 0" descr="C:\Users\magda\AppData\Local\Temp\gg_out_1790976058915.png">    </p:cNvPr>
           <p:cNvPicPr>
             <a:picLocks noChangeAspect="1"/>
           </p:cNvPicPr>
@@ -8151,7 +8227,7 @@
       </p:sp>
       <p:pic>
         <p:nvPicPr>
-          <p:cNvPr id="4" name="Image 0" descr="C:\Users\magda\AppData\Local\Temp\gg_out_1788477044773.png">    </p:cNvPr>
+          <p:cNvPr id="4" name="Image 0" descr="C:\Users\magda\AppData\Local\Temp\gg_out_1790976062286.png">    </p:cNvPr>
           <p:cNvPicPr>
             <a:picLocks noChangeAspect="1"/>
           </p:cNvPicPr>
@@ -10809,7 +10885,7 @@
         <p:spPr>
           <a:xfrm rot="-108000">
             <a:off x="539496" y="1208837"/>
-            <a:ext cx="1600200" cy="515722"/>
+            <a:ext cx="1046566" cy="859536"/>
           </a:xfrm>
           <a:prstGeom prst="rect">
             <a:avLst/>
@@ -10847,8 +10923,8 @@
         </p:nvSpPr>
         <p:spPr>
           <a:xfrm rot="72000">
-            <a:off x="2011680" y="1184148"/>
-            <a:ext cx="886968" cy="515722"/>
+            <a:off x="1458046" y="1184148"/>
+            <a:ext cx="658912" cy="859536"/>
           </a:xfrm>
           <a:prstGeom prst="rect">
             <a:avLst/>
@@ -10886,8 +10962,8 @@
         </p:nvSpPr>
         <p:spPr>
           <a:xfrm rot="-90000">
-            <a:off x="2770632" y="1206094"/>
-            <a:ext cx="411480" cy="515722"/>
+            <a:off x="1988942" y="1206094"/>
+            <a:ext cx="387157" cy="859536"/>
           </a:xfrm>
           <a:prstGeom prst="rect">
             <a:avLst/>
@@ -10925,8 +11001,8 @@
         </p:nvSpPr>
         <p:spPr>
           <a:xfrm rot="108000">
-            <a:off x="3054096" y="1186891"/>
-            <a:ext cx="1600200" cy="515722"/>
+            <a:off x="2248083" y="1186891"/>
+            <a:ext cx="920760" cy="859536"/>
           </a:xfrm>
           <a:prstGeom prst="rect">
             <a:avLst/>
@@ -10964,8 +11040,8 @@
         </p:nvSpPr>
         <p:spPr>
           <a:xfrm rot="-54000">
-            <a:off x="539496" y="1730045"/>
-            <a:ext cx="1837944" cy="515722"/>
+            <a:off x="3040827" y="1214323"/>
+            <a:ext cx="1073313" cy="859536"/>
           </a:xfrm>
           <a:prstGeom prst="rect">
             <a:avLst/>
@@ -11003,8 +11079,8 @@
         </p:nvSpPr>
         <p:spPr>
           <a:xfrm rot="90000">
-            <a:off x="2249424" y="1705356"/>
-            <a:ext cx="1362456" cy="515722"/>
+            <a:off x="3986124" y="1189634"/>
+            <a:ext cx="828965" cy="859536"/>
           </a:xfrm>
           <a:prstGeom prst="rect">
             <a:avLst/>
@@ -11042,8 +11118,8 @@
         </p:nvSpPr>
         <p:spPr>
           <a:xfrm rot="-36000">
-            <a:off x="3483864" y="1724558"/>
-            <a:ext cx="1124712" cy="515722"/>
+            <a:off x="4687072" y="1208837"/>
+            <a:ext cx="829295" cy="859536"/>
           </a:xfrm>
           <a:prstGeom prst="rect">
             <a:avLst/>
@@ -11081,8 +11157,8 @@
         </p:nvSpPr>
         <p:spPr>
           <a:xfrm rot="-108000">
-            <a:off x="4480560" y="1724558"/>
-            <a:ext cx="1124712" cy="515722"/>
+            <a:off x="539496" y="2068373"/>
+            <a:ext cx="704809" cy="859536"/>
           </a:xfrm>
           <a:prstGeom prst="rect">
             <a:avLst/>
@@ -11120,8 +11196,8 @@
         </p:nvSpPr>
         <p:spPr>
           <a:xfrm rot="72000">
-            <a:off x="539496" y="2215591"/>
-            <a:ext cx="2313432" cy="515722"/>
+            <a:off x="1116289" y="2043684"/>
+            <a:ext cx="1209685" cy="859536"/>
           </a:xfrm>
           <a:prstGeom prst="rect">
             <a:avLst/>
@@ -11159,8 +11235,8 @@
         </p:nvSpPr>
         <p:spPr>
           <a:xfrm rot="-90000">
-            <a:off x="2724912" y="2237537"/>
-            <a:ext cx="886968" cy="515722"/>
+            <a:off x="2197959" y="2065630"/>
+            <a:ext cx="658912" cy="859536"/>
           </a:xfrm>
           <a:prstGeom prst="rect">
             <a:avLst/>
@@ -11198,8 +11274,8 @@
         </p:nvSpPr>
         <p:spPr>
           <a:xfrm rot="108000">
-            <a:off x="3483864" y="2218334"/>
-            <a:ext cx="886968" cy="515722"/>
+            <a:off x="2728854" y="2046427"/>
+            <a:ext cx="570088" cy="859536"/>
           </a:xfrm>
           <a:prstGeom prst="rect">
             <a:avLst/>
@@ -11237,8 +11313,8 @@
         </p:nvSpPr>
         <p:spPr>
           <a:xfrm rot="-54000">
-            <a:off x="4242816" y="2245766"/>
-            <a:ext cx="886968" cy="515722"/>
+            <a:off x="3170926" y="2073859"/>
+            <a:ext cx="615655" cy="859536"/>
           </a:xfrm>
           <a:prstGeom prst="rect">
             <a:avLst/>
@@ -11276,8 +11352,8 @@
         </p:nvSpPr>
         <p:spPr>
           <a:xfrm rot="90000">
-            <a:off x="539496" y="2736799"/>
-            <a:ext cx="1600200" cy="515722"/>
+            <a:off x="3658565" y="2049170"/>
+            <a:ext cx="1009584" cy="859536"/>
           </a:xfrm>
           <a:prstGeom prst="rect">
             <a:avLst/>
@@ -11315,8 +11391,8 @@
         </p:nvSpPr>
         <p:spPr>
           <a:xfrm rot="-36000">
-            <a:off x="2011680" y="2756002"/>
-            <a:ext cx="649224" cy="515722"/>
+            <a:off x="4540133" y="2068373"/>
+            <a:ext cx="496453" cy="859536"/>
           </a:xfrm>
           <a:prstGeom prst="rect">
             <a:avLst/>
@@ -11354,8 +11430,8 @@
         </p:nvSpPr>
         <p:spPr>
           <a:xfrm rot="-108000">
-            <a:off x="2532888" y="2756002"/>
-            <a:ext cx="1362456" cy="515722"/>
+            <a:off x="4908570" y="2068373"/>
+            <a:ext cx="806841" cy="859536"/>
           </a:xfrm>
           <a:prstGeom prst="rect">
             <a:avLst/>
@@ -11393,8 +11469,8 @@
         </p:nvSpPr>
         <p:spPr>
           <a:xfrm rot="72000">
-            <a:off x="3767328" y="2731313"/>
-            <a:ext cx="649224" cy="515722"/>
+            <a:off x="539496" y="2903220"/>
+            <a:ext cx="522869" cy="859536"/>
           </a:xfrm>
           <a:prstGeom prst="rect">
             <a:avLst/>
@@ -11432,8 +11508,8 @@
         </p:nvSpPr>
         <p:spPr>
           <a:xfrm rot="-90000">
-            <a:off x="539496" y="3268980"/>
-            <a:ext cx="2551176" cy="515722"/>
+            <a:off x="934349" y="2925166"/>
+            <a:ext cx="1228837" cy="859536"/>
           </a:xfrm>
           <a:prstGeom prst="rect">
             <a:avLst/>
@@ -11471,8 +11547,8 @@
         </p:nvSpPr>
         <p:spPr>
           <a:xfrm rot="108000">
-            <a:off x="2962656" y="3249778"/>
-            <a:ext cx="886968" cy="515722"/>
+            <a:off x="2035170" y="2905963"/>
+            <a:ext cx="616316" cy="859536"/>
           </a:xfrm>
           <a:prstGeom prst="rect">
             <a:avLst/>
@@ -11510,8 +11586,8 @@
         </p:nvSpPr>
         <p:spPr>
           <a:xfrm rot="-54000">
-            <a:off x="3721608" y="3277210"/>
-            <a:ext cx="1124712" cy="515722"/>
+            <a:off x="2523470" y="2933395"/>
+            <a:ext cx="776463" cy="859536"/>
           </a:xfrm>
           <a:prstGeom prst="rect">
             <a:avLst/>
@@ -11549,8 +11625,8 @@
         </p:nvSpPr>
         <p:spPr>
           <a:xfrm rot="90000">
-            <a:off x="539496" y="3768242"/>
-            <a:ext cx="2313432" cy="515722"/>
+            <a:off x="3171916" y="2908706"/>
+            <a:ext cx="1251290" cy="859536"/>
           </a:xfrm>
           <a:prstGeom prst="rect">
             <a:avLst/>
@@ -11588,8 +11664,8 @@
         </p:nvSpPr>
         <p:spPr>
           <a:xfrm rot="-36000">
-            <a:off x="2724912" y="3787445"/>
-            <a:ext cx="1124712" cy="515722"/>
+            <a:off x="4295191" y="2927909"/>
+            <a:ext cx="786369" cy="859536"/>
           </a:xfrm>
           <a:prstGeom prst="rect">
             <a:avLst/>
@@ -11627,8 +11703,8 @@
         </p:nvSpPr>
         <p:spPr>
           <a:xfrm rot="-108000">
-            <a:off x="3721608" y="3787445"/>
-            <a:ext cx="1124712" cy="515722"/>
+            <a:off x="4953544" y="2927909"/>
+            <a:ext cx="705470" cy="859536"/>
           </a:xfrm>
           <a:prstGeom prst="rect">
             <a:avLst/>
@@ -11666,8 +11742,8 @@
         </p:nvSpPr>
         <p:spPr>
           <a:xfrm rot="72000">
-            <a:off x="4718304" y="3762756"/>
-            <a:ext cx="886968" cy="515722"/>
+            <a:off x="539496" y="3762756"/>
+            <a:ext cx="552257" cy="859536"/>
           </a:xfrm>
           <a:prstGeom prst="rect">
             <a:avLst/>
@@ -11705,8 +11781,8 @@
         </p:nvSpPr>
         <p:spPr>
           <a:xfrm rot="-90000">
-            <a:off x="539496" y="4300423"/>
-            <a:ext cx="1124712" cy="515722"/>
+            <a:off x="963737" y="3784702"/>
+            <a:ext cx="848777" cy="859536"/>
           </a:xfrm>
           <a:prstGeom prst="rect">
             <a:avLst/>
@@ -11744,8 +11820,8 @@
         </p:nvSpPr>
         <p:spPr>
           <a:xfrm rot="108000">
-            <a:off x="1536192" y="4281221"/>
-            <a:ext cx="1124712" cy="515722"/>
+            <a:off x="1684498" y="3765499"/>
+            <a:ext cx="806181" cy="859536"/>
           </a:xfrm>
           <a:prstGeom prst="rect">
             <a:avLst/>
@@ -11783,8 +11859,8 @@
         </p:nvSpPr>
         <p:spPr>
           <a:xfrm rot="-54000">
-            <a:off x="2532888" y="4308653"/>
-            <a:ext cx="649224" cy="515722"/>
+            <a:off x="2362662" y="3792931"/>
+            <a:ext cx="458480" cy="859536"/>
           </a:xfrm>
           <a:prstGeom prst="rect">
             <a:avLst/>
@@ -11822,8 +11898,8 @@
         </p:nvSpPr>
         <p:spPr>
           <a:xfrm rot="90000">
-            <a:off x="3054096" y="4283964"/>
-            <a:ext cx="1600200" cy="515722"/>
+            <a:off x="2693126" y="3768242"/>
+            <a:ext cx="1009584" cy="859536"/>
           </a:xfrm>
           <a:prstGeom prst="rect">
             <a:avLst/>
@@ -11861,8 +11937,8 @@
         </p:nvSpPr>
         <p:spPr>
           <a:xfrm rot="-36000">
-            <a:off x="4526280" y="4303166"/>
-            <a:ext cx="649224" cy="515722"/>
+            <a:off x="3574694" y="3787445"/>
+            <a:ext cx="474990" cy="859536"/>
           </a:xfrm>
           <a:prstGeom prst="rect">
             <a:avLst/>
@@ -11900,8 +11976,8 @@
         </p:nvSpPr>
         <p:spPr>
           <a:xfrm rot="-108000">
-            <a:off x="539496" y="4818888"/>
-            <a:ext cx="886968" cy="515722"/>
+            <a:off x="3921669" y="3787445"/>
+            <a:ext cx="615655" cy="859536"/>
           </a:xfrm>
           <a:prstGeom prst="rect">
             <a:avLst/>
@@ -11939,8 +12015,8 @@
         </p:nvSpPr>
         <p:spPr>
           <a:xfrm rot="72000">
-            <a:off x="1298448" y="4794199"/>
-            <a:ext cx="1124712" cy="515722"/>
+            <a:off x="4409308" y="3762756"/>
+            <a:ext cx="800898" cy="859536"/>
           </a:xfrm>
           <a:prstGeom prst="rect">
             <a:avLst/>
@@ -11978,8 +12054,8 @@
         </p:nvSpPr>
         <p:spPr>
           <a:xfrm rot="-90000">
-            <a:off x="2295144" y="4816145"/>
-            <a:ext cx="1362456" cy="515722"/>
+            <a:off x="5082189" y="3784702"/>
+            <a:ext cx="784057" cy="859536"/>
           </a:xfrm>
           <a:prstGeom prst="rect">
             <a:avLst/>
@@ -12017,8 +12093,8 @@
         </p:nvSpPr>
         <p:spPr>
           <a:xfrm rot="108000">
-            <a:off x="3529584" y="4796942"/>
-            <a:ext cx="1124712" cy="515722"/>
+            <a:off x="539496" y="4625035"/>
+            <a:ext cx="688299" cy="859536"/>
           </a:xfrm>
           <a:prstGeom prst="rect">
             <a:avLst/>
@@ -12056,8 +12132,8 @@
         </p:nvSpPr>
         <p:spPr>
           <a:xfrm rot="-54000">
-            <a:off x="4526280" y="4824374"/>
-            <a:ext cx="886968" cy="515722"/>
+            <a:off x="1099779" y="4652467"/>
+            <a:ext cx="657591" cy="859536"/>
           </a:xfrm>
           <a:prstGeom prst="rect">
             <a:avLst/>
@@ -12095,8 +12171,8 @@
         </p:nvSpPr>
         <p:spPr>
           <a:xfrm rot="90000">
-            <a:off x="539496" y="5315407"/>
-            <a:ext cx="1362456" cy="515722"/>
+            <a:off x="1629354" y="4627778"/>
+            <a:ext cx="820710" cy="859536"/>
           </a:xfrm>
           <a:prstGeom prst="rect">
             <a:avLst/>
@@ -12134,8 +12210,8 @@
         </p:nvSpPr>
         <p:spPr>
           <a:xfrm rot="-36000">
-            <a:off x="1773936" y="5334610"/>
-            <a:ext cx="649224" cy="515722"/>
+            <a:off x="2322048" y="4646981"/>
+            <a:ext cx="420177" cy="859536"/>
           </a:xfrm>
           <a:prstGeom prst="rect">
             <a:avLst/>
@@ -12173,8 +12249,8 @@
         </p:nvSpPr>
         <p:spPr>
           <a:xfrm rot="-108000">
-            <a:off x="2295144" y="5334610"/>
-            <a:ext cx="1837944" cy="515722"/>
+            <a:off x="2614209" y="4646981"/>
+            <a:ext cx="1039302" cy="859536"/>
           </a:xfrm>
           <a:prstGeom prst="rect">
             <a:avLst/>
@@ -12212,8 +12288,8 @@
         </p:nvSpPr>
         <p:spPr>
           <a:xfrm rot="72000">
-            <a:off x="4005072" y="5309921"/>
-            <a:ext cx="886968" cy="515722"/>
+            <a:off x="3525495" y="4622292"/>
+            <a:ext cx="617967" cy="859536"/>
           </a:xfrm>
           <a:prstGeom prst="rect">
             <a:avLst/>
@@ -12251,8 +12327,8 @@
         </p:nvSpPr>
         <p:spPr>
           <a:xfrm rot="-90000">
-            <a:off x="539496" y="5847588"/>
-            <a:ext cx="1124712" cy="515722"/>
+            <a:off x="4015445" y="4644238"/>
+            <a:ext cx="750047" cy="859536"/>
           </a:xfrm>
           <a:prstGeom prst="rect">
             <a:avLst/>
@@ -12290,8 +12366,8 @@
         </p:nvSpPr>
         <p:spPr>
           <a:xfrm rot="108000">
-            <a:off x="1536192" y="5828386"/>
-            <a:ext cx="649224" cy="515722"/>
+            <a:off x="4637476" y="4625035"/>
+            <a:ext cx="496453" cy="859536"/>
           </a:xfrm>
           <a:prstGeom prst="rect">
             <a:avLst/>
@@ -12329,8 +12405,8 @@
         </p:nvSpPr>
         <p:spPr>
           <a:xfrm rot="-54000">
-            <a:off x="2057400" y="5855818"/>
-            <a:ext cx="886968" cy="515722"/>
+            <a:off x="5005913" y="4652467"/>
+            <a:ext cx="615655" cy="859536"/>
           </a:xfrm>
           <a:prstGeom prst="rect">
             <a:avLst/>
@@ -12368,8 +12444,8 @@
         </p:nvSpPr>
         <p:spPr>
           <a:xfrm rot="90000">
-            <a:off x="2816352" y="5831129"/>
-            <a:ext cx="1124712" cy="515722"/>
+            <a:off x="539496" y="5487314"/>
+            <a:ext cx="800898" cy="859536"/>
           </a:xfrm>
           <a:prstGeom prst="rect">
             <a:avLst/>
@@ -12407,8 +12483,8 @@
         </p:nvSpPr>
         <p:spPr>
           <a:xfrm rot="-36000">
-            <a:off x="3813048" y="5850331"/>
-            <a:ext cx="1837944" cy="515722"/>
+            <a:off x="1212378" y="5506517"/>
+            <a:ext cx="1022132" cy="859536"/>
           </a:xfrm>
           <a:prstGeom prst="rect">
             <a:avLst/>
@@ -12446,7 +12522,7 @@
         </p:nvSpPr>
         <p:spPr>
           <a:xfrm>
-            <a:off x="539496" y="1713586"/>
+            <a:off x="539496" y="2057400"/>
             <a:ext cx="5153924" cy="0"/>
           </a:xfrm>
           <a:prstGeom prst="line">
@@ -12469,7 +12545,7 @@
         </p:nvSpPr>
         <p:spPr>
           <a:xfrm>
-            <a:off x="539496" y="2229307"/>
+            <a:off x="539496" y="2916936"/>
             <a:ext cx="5153924" cy="0"/>
           </a:xfrm>
           <a:prstGeom prst="line">
@@ -12492,7 +12568,7 @@
         </p:nvSpPr>
         <p:spPr>
           <a:xfrm>
-            <a:off x="539496" y="2745029"/>
+            <a:off x="539496" y="3776472"/>
             <a:ext cx="5153924" cy="0"/>
           </a:xfrm>
           <a:prstGeom prst="line">
@@ -12515,7 +12591,7 @@
         </p:nvSpPr>
         <p:spPr>
           <a:xfrm>
-            <a:off x="539496" y="3260750"/>
+            <a:off x="539496" y="4636008"/>
             <a:ext cx="5153924" cy="0"/>
           </a:xfrm>
           <a:prstGeom prst="line">
@@ -12538,7 +12614,7 @@
         </p:nvSpPr>
         <p:spPr>
           <a:xfrm>
-            <a:off x="539496" y="3776472"/>
+            <a:off x="539496" y="5495544"/>
             <a:ext cx="5153924" cy="0"/>
           </a:xfrm>
           <a:prstGeom prst="line">
@@ -12561,7 +12637,7 @@
         </p:nvSpPr>
         <p:spPr>
           <a:xfrm>
-            <a:off x="539496" y="4292194"/>
+            <a:off x="539496" y="6355080"/>
             <a:ext cx="5153924" cy="0"/>
           </a:xfrm>
           <a:prstGeom prst="line">
@@ -12578,99 +12654,7 @@
       </p:sp>
       <p:sp>
         <p:nvSpPr>
-          <p:cNvPr id="59" name="Shape 57"/>
-          <p:cNvSpPr/>
-          <p:nvPr/>
-        </p:nvSpPr>
-        <p:spPr>
-          <a:xfrm>
-            <a:off x="539496" y="4807915"/>
-            <a:ext cx="5153924" cy="0"/>
-          </a:xfrm>
-          <a:prstGeom prst="line">
-            <a:avLst/>
-          </a:prstGeom>
-          <a:noFill/>
-          <a:ln w="9525">
-            <a:solidFill>
-              <a:srgbClr val="C9C9DC"/>
-            </a:solidFill>
-            <a:prstDash val="solid"/>
-          </a:ln>
-        </p:spPr>
-      </p:sp>
-      <p:sp>
-        <p:nvSpPr>
-          <p:cNvPr id="60" name="Shape 58"/>
-          <p:cNvSpPr/>
-          <p:nvPr/>
-        </p:nvSpPr>
-        <p:spPr>
-          <a:xfrm>
-            <a:off x="539496" y="5323637"/>
-            <a:ext cx="5153924" cy="0"/>
-          </a:xfrm>
-          <a:prstGeom prst="line">
-            <a:avLst/>
-          </a:prstGeom>
-          <a:noFill/>
-          <a:ln w="9525">
-            <a:solidFill>
-              <a:srgbClr val="C9C9DC"/>
-            </a:solidFill>
-            <a:prstDash val="solid"/>
-          </a:ln>
-        </p:spPr>
-      </p:sp>
-      <p:sp>
-        <p:nvSpPr>
-          <p:cNvPr id="61" name="Shape 59"/>
-          <p:cNvSpPr/>
-          <p:nvPr/>
-        </p:nvSpPr>
-        <p:spPr>
-          <a:xfrm>
-            <a:off x="539496" y="5839358"/>
-            <a:ext cx="5153924" cy="0"/>
-          </a:xfrm>
-          <a:prstGeom prst="line">
-            <a:avLst/>
-          </a:prstGeom>
-          <a:noFill/>
-          <a:ln w="9525">
-            <a:solidFill>
-              <a:srgbClr val="C9C9DC"/>
-            </a:solidFill>
-            <a:prstDash val="solid"/>
-          </a:ln>
-        </p:spPr>
-      </p:sp>
-      <p:sp>
-        <p:nvSpPr>
-          <p:cNvPr id="62" name="Shape 60"/>
-          <p:cNvSpPr/>
-          <p:nvPr/>
-        </p:nvSpPr>
-        <p:spPr>
-          <a:xfrm>
-            <a:off x="539496" y="6355080"/>
-            <a:ext cx="5153924" cy="0"/>
-          </a:xfrm>
-          <a:prstGeom prst="line">
-            <a:avLst/>
-          </a:prstGeom>
-          <a:noFill/>
-          <a:ln w="9525">
-            <a:solidFill>
-              <a:srgbClr val="C9C9DC"/>
-            </a:solidFill>
-            <a:prstDash val="solid"/>
-          </a:ln>
-        </p:spPr>
-      </p:sp>
-      <p:sp>
-        <p:nvSpPr>
-          <p:cNvPr id="63" name="Text 61"/>
+          <p:cNvPr id="59" name="Text 57"/>
           <p:cNvSpPr/>
           <p:nvPr/>
         </p:nvSpPr>
@@ -13369,7 +13353,7 @@
       </p:sp>
       <p:sp>
         <p:nvSpPr>
-          <p:cNvPr id="64" name="Text 62"/>
+          <p:cNvPr id="60" name="Text 58"/>
           <p:cNvSpPr/>
           <p:nvPr/>
         </p:nvSpPr>
@@ -13795,7 +13779,7 @@
         <p:spPr>
           <a:xfrm rot="-36000">
             <a:off x="539496" y="1197864"/>
-            <a:ext cx="1051560" cy="1133856"/>
+            <a:ext cx="679643" cy="1133856"/>
           </a:xfrm>
           <a:prstGeom prst="rect">
             <a:avLst/>
@@ -13833,8 +13817,8 @@
         </p:nvSpPr>
         <p:spPr>
           <a:xfrm rot="18000">
-            <a:off x="1463040" y="1203350"/>
-            <a:ext cx="393192" cy="1133856"/>
+            <a:off x="1091123" y="1203350"/>
+            <a:ext cx="367223" cy="1133856"/>
           </a:xfrm>
           <a:prstGeom prst="rect">
             <a:avLst/>
@@ -13872,8 +13856,8 @@
         </p:nvSpPr>
         <p:spPr>
           <a:xfrm rot="-18000">
-            <a:off x="1728216" y="1192378"/>
-            <a:ext cx="393192" cy="1133856"/>
+            <a:off x="1330330" y="1192378"/>
+            <a:ext cx="380634" cy="1133856"/>
           </a:xfrm>
           <a:prstGeom prst="rect">
             <a:avLst/>
@@ -13911,8 +13895,8 @@
         </p:nvSpPr>
         <p:spPr>
           <a:xfrm rot="36000">
-            <a:off x="1993392" y="1200607"/>
-            <a:ext cx="393192" cy="1133856"/>
+            <a:off x="1582948" y="1200607"/>
+            <a:ext cx="367223" cy="1133856"/>
           </a:xfrm>
           <a:prstGeom prst="rect">
             <a:avLst/>
@@ -13950,8 +13934,8 @@
         </p:nvSpPr>
         <p:spPr>
           <a:xfrm>
-            <a:off x="2258568" y="1195121"/>
-            <a:ext cx="393192" cy="1133856"/>
+            <a:off x="1822155" y="1195121"/>
+            <a:ext cx="332171" cy="1133856"/>
           </a:xfrm>
           <a:prstGeom prst="rect">
             <a:avLst/>
@@ -13990,7 +13974,7 @@
         <p:spPr>
           <a:xfrm rot="-36000">
             <a:off x="539496" y="2331720"/>
-            <a:ext cx="1051560" cy="1133856"/>
+            <a:ext cx="679643" cy="1133856"/>
           </a:xfrm>
           <a:prstGeom prst="rect">
             <a:avLst/>
@@ -14028,8 +14012,8 @@
         </p:nvSpPr>
         <p:spPr>
           <a:xfrm rot="18000">
-            <a:off x="1463040" y="2337206"/>
-            <a:ext cx="393192" cy="1133856"/>
+            <a:off x="1091123" y="2337206"/>
+            <a:ext cx="367223" cy="1133856"/>
           </a:xfrm>
           <a:prstGeom prst="rect">
             <a:avLst/>
@@ -14067,8 +14051,8 @@
         </p:nvSpPr>
         <p:spPr>
           <a:xfrm rot="-18000">
-            <a:off x="1728216" y="2326234"/>
-            <a:ext cx="612648" cy="1133856"/>
+            <a:off x="1330330" y="2326234"/>
+            <a:ext cx="505602" cy="1133856"/>
           </a:xfrm>
           <a:prstGeom prst="rect">
             <a:avLst/>
@@ -14106,8 +14090,8 @@
         </p:nvSpPr>
         <p:spPr>
           <a:xfrm rot="36000">
-            <a:off x="2212848" y="2334463"/>
-            <a:ext cx="393192" cy="1133856"/>
+            <a:off x="1707916" y="2334463"/>
+            <a:ext cx="367223" cy="1133856"/>
           </a:xfrm>
           <a:prstGeom prst="rect">
             <a:avLst/>
@@ -14145,8 +14129,8 @@
         </p:nvSpPr>
         <p:spPr>
           <a:xfrm>
-            <a:off x="2478024" y="2328977"/>
-            <a:ext cx="612648" cy="1133856"/>
+            <a:off x="1947123" y="2328977"/>
+            <a:ext cx="512003" cy="1133856"/>
           </a:xfrm>
           <a:prstGeom prst="rect">
             <a:avLst/>
@@ -14185,7 +14169,7 @@
         <p:spPr>
           <a:xfrm rot="-36000">
             <a:off x="539496" y="3465576"/>
-            <a:ext cx="1051560" cy="1133856"/>
+            <a:ext cx="679643" cy="1133856"/>
           </a:xfrm>
           <a:prstGeom prst="rect">
             <a:avLst/>
@@ -14223,8 +14207,8 @@
         </p:nvSpPr>
         <p:spPr>
           <a:xfrm rot="18000">
-            <a:off x="1463040" y="3471062"/>
-            <a:ext cx="393192" cy="1133856"/>
+            <a:off x="1091123" y="3471062"/>
+            <a:ext cx="367223" cy="1133856"/>
           </a:xfrm>
           <a:prstGeom prst="rect">
             <a:avLst/>
@@ -14262,8 +14246,8 @@
         </p:nvSpPr>
         <p:spPr>
           <a:xfrm rot="-18000">
-            <a:off x="1728216" y="3460090"/>
-            <a:ext cx="832104" cy="1133856"/>
+            <a:off x="1330330" y="3460090"/>
+            <a:ext cx="565953" cy="1133856"/>
           </a:xfrm>
           <a:prstGeom prst="rect">
             <a:avLst/>
@@ -14301,8 +14285,8 @@
         </p:nvSpPr>
         <p:spPr>
           <a:xfrm rot="36000">
-            <a:off x="2432304" y="3468319"/>
-            <a:ext cx="1271016" cy="1133856"/>
+            <a:off x="1768267" y="3468319"/>
+            <a:ext cx="820461" cy="1133856"/>
           </a:xfrm>
           <a:prstGeom prst="rect">
             <a:avLst/>
@@ -15066,7 +15050,7 @@
       </p:sp>
       <p:pic>
         <p:nvPicPr>
-          <p:cNvPr id="10" name="Image 0" descr="C:\Users\magda\AppData\Local\Temp\gg_out_1788477037979.png">    </p:cNvPr>
+          <p:cNvPr id="10" name="Image 0" descr="C:\Users\magda\AppData\Local\Temp\gg_out_1790976047964.png">    </p:cNvPr>
           <p:cNvPicPr>
             <a:picLocks noChangeAspect="1"/>
           </p:cNvPicPr>
@@ -16585,7 +16569,7 @@
         <p:spPr>
           <a:xfrm rot="-72000">
             <a:off x="5404653" y="2392070"/>
-            <a:ext cx="1042416" cy="484632"/>
+            <a:ext cx="682475" cy="897636"/>
           </a:xfrm>
           <a:prstGeom prst="rect">
             <a:avLst/>
@@ -16623,8 +16607,8 @@
         </p:nvSpPr>
         <p:spPr>
           <a:xfrm rot="54000">
-            <a:off x="6319053" y="2378354"/>
-            <a:ext cx="521208" cy="484632"/>
+            <a:off x="5959112" y="2378354"/>
+            <a:ext cx="341518" cy="897636"/>
           </a:xfrm>
           <a:prstGeom prst="rect">
             <a:avLst/>
@@ -16662,8 +16646,8 @@
         </p:nvSpPr>
         <p:spPr>
           <a:xfrm rot="-36000">
-            <a:off x="6712245" y="2397557"/>
-            <a:ext cx="868680" cy="484632"/>
+            <a:off x="6172614" y="2397557"/>
+            <a:ext cx="601881" cy="897636"/>
           </a:xfrm>
           <a:prstGeom prst="rect">
             <a:avLst/>
@@ -16701,8 +16685,8 @@
         </p:nvSpPr>
         <p:spPr>
           <a:xfrm rot="72000">
-            <a:off x="7452909" y="2381098"/>
-            <a:ext cx="868680" cy="484632"/>
+            <a:off x="6646479" y="2381098"/>
+            <a:ext cx="549519" cy="897636"/>
           </a:xfrm>
           <a:prstGeom prst="rect">
             <a:avLst/>
@@ -16740,8 +16724,8 @@
         </p:nvSpPr>
         <p:spPr>
           <a:xfrm rot="-18000">
-            <a:off x="8193573" y="2394814"/>
-            <a:ext cx="521208" cy="484632"/>
+            <a:off x="7067982" y="2394814"/>
+            <a:ext cx="381574" cy="897636"/>
           </a:xfrm>
           <a:prstGeom prst="rect">
             <a:avLst/>
@@ -16779,8 +16763,8 @@
         </p:nvSpPr>
         <p:spPr>
           <a:xfrm rot="36000">
-            <a:off x="8586765" y="2375611"/>
-            <a:ext cx="521208" cy="484632"/>
+            <a:off x="7321540" y="2375611"/>
+            <a:ext cx="336934" cy="897636"/>
           </a:xfrm>
           <a:prstGeom prst="rect">
             <a:avLst/>
@@ -16818,8 +16802,8 @@
         </p:nvSpPr>
         <p:spPr>
           <a:xfrm rot="-72000">
-            <a:off x="8979957" y="2392070"/>
-            <a:ext cx="868680" cy="484632"/>
+            <a:off x="7530457" y="2392070"/>
+            <a:ext cx="550001" cy="897636"/>
           </a:xfrm>
           <a:prstGeom prst="rect">
             <a:avLst/>
@@ -16857,8 +16841,8 @@
         </p:nvSpPr>
         <p:spPr>
           <a:xfrm rot="54000">
-            <a:off x="9720621" y="2378354"/>
-            <a:ext cx="1389888" cy="484632"/>
+            <a:off x="7952443" y="2378354"/>
+            <a:ext cx="769343" cy="897636"/>
           </a:xfrm>
           <a:prstGeom prst="rect">
             <a:avLst/>
@@ -16896,8 +16880,8 @@
         </p:nvSpPr>
         <p:spPr>
           <a:xfrm rot="-36000">
-            <a:off x="10982493" y="2397557"/>
-            <a:ext cx="694944" cy="484632"/>
+            <a:off x="8593770" y="2397557"/>
+            <a:ext cx="515013" cy="897636"/>
           </a:xfrm>
           <a:prstGeom prst="rect">
             <a:avLst/>
@@ -16935,8 +16919,8 @@
         </p:nvSpPr>
         <p:spPr>
           <a:xfrm rot="72000">
-            <a:off x="5404653" y="2865730"/>
-            <a:ext cx="1737360" cy="484632"/>
+            <a:off x="8980767" y="2381098"/>
+            <a:ext cx="918467" cy="897636"/>
           </a:xfrm>
           <a:prstGeom prst="rect">
             <a:avLst/>
@@ -16974,8 +16958,8 @@
         </p:nvSpPr>
         <p:spPr>
           <a:xfrm rot="-18000">
-            <a:off x="7013997" y="2879446"/>
-            <a:ext cx="868680" cy="484632"/>
+            <a:off x="9771217" y="2394814"/>
+            <a:ext cx="634698" cy="897636"/>
           </a:xfrm>
           <a:prstGeom prst="rect">
             <a:avLst/>
@@ -17013,8 +16997,8 @@
         </p:nvSpPr>
         <p:spPr>
           <a:xfrm rot="36000">
-            <a:off x="7754661" y="2860243"/>
-            <a:ext cx="1042416" cy="484632"/>
+            <a:off x="10277899" y="2375611"/>
+            <a:ext cx="649658" cy="897636"/>
           </a:xfrm>
           <a:prstGeom prst="rect">
             <a:avLst/>
@@ -17052,7 +17036,7 @@
         </p:nvSpPr>
         <p:spPr>
           <a:xfrm>
-            <a:off x="5404653" y="2871216"/>
+            <a:off x="5404653" y="3284220"/>
             <a:ext cx="6199083" cy="0"/>
           </a:xfrm>
           <a:prstGeom prst="line">
@@ -17069,13 +17053,820 @@
       </p:sp>
       <p:sp>
         <p:nvSpPr>
-          <p:cNvPr id="28" name="Shape 26"/>
-          <p:cNvSpPr/>
-          <p:nvPr/>
-        </p:nvSpPr>
-        <p:spPr>
-          <a:xfrm>
-            <a:off x="5404653" y="3355848"/>
+          <p:cNvPr id="28" name="Text 26"/>
+          <p:cNvSpPr/>
+          <p:nvPr/>
+        </p:nvSpPr>
+        <p:spPr>
+          <a:xfrm>
+            <a:off x="5276637" y="3538728"/>
+            <a:ext cx="6500835" cy="237744"/>
+          </a:xfrm>
+          <a:prstGeom prst="rect">
+            <a:avLst/>
+          </a:prstGeom>
+          <a:solidFill>
+            <a:srgbClr val="0D1B5E"/>
+          </a:solidFill>
+          <a:ln/>
+        </p:spPr>
+        <p:txBody>
+          <a:bodyPr wrap="square" lIns="76200" tIns="76200" rIns="76200" bIns="76200" rtlCol="0" anchor="ctr"/>
+          <a:lstStyle/>
+          <a:p>
+            <a:pPr algn="l" indent="0" marL="0">
+              <a:buNone/>
+            </a:pPr>
+            <a:r>
+              <a:rPr lang="en-US" sz="1200" b="1" dirty="0">
+                <a:solidFill>
+                  <a:srgbClr val="FABB2E"/>
+                </a:solidFill>
+                <a:latin typeface="Trebuchet MS" pitchFamily="34" charset="0"/>
+                <a:ea typeface="Trebuchet MS" pitchFamily="34" charset="-122"/>
+                <a:cs typeface="Trebuchet MS" pitchFamily="34" charset="-120"/>
+              </a:rPr>
+              <a:t>Student B</a:t>
+            </a:r>
+            <a:endParaRPr lang="en-US" sz="1200" dirty="0"/>
+          </a:p>
+        </p:txBody>
+      </p:sp>
+      <p:sp>
+        <p:nvSpPr>
+          <p:cNvPr id="29" name="Shape 27"/>
+          <p:cNvSpPr/>
+          <p:nvPr/>
+        </p:nvSpPr>
+        <p:spPr>
+          <a:xfrm>
+            <a:off x="5276637" y="3776472"/>
+            <a:ext cx="6500835" cy="1188720"/>
+          </a:xfrm>
+          <a:prstGeom prst="rect">
+            <a:avLst/>
+          </a:prstGeom>
+          <a:solidFill>
+            <a:srgbClr val="FFFFFF"/>
+          </a:solidFill>
+          <a:ln w="25400">
+            <a:solidFill>
+              <a:srgbClr val="FABB2E"/>
+            </a:solidFill>
+            <a:prstDash val="solid"/>
+          </a:ln>
+        </p:spPr>
+      </p:sp>
+      <p:sp>
+        <p:nvSpPr>
+          <p:cNvPr id="30" name="Text 28"/>
+          <p:cNvSpPr/>
+          <p:nvPr/>
+        </p:nvSpPr>
+        <p:spPr>
+          <a:xfrm rot="-162000">
+            <a:off x="5404653" y="3902659"/>
+            <a:ext cx="640489" cy="484632"/>
+          </a:xfrm>
+          <a:prstGeom prst="rect">
+            <a:avLst/>
+          </a:prstGeom>
+          <a:noFill/>
+          <a:ln/>
+        </p:spPr>
+        <p:txBody>
+          <a:bodyPr wrap="square" lIns="0" tIns="0" rIns="0" bIns="0" rtlCol="0" anchor="b"/>
+          <a:lstStyle/>
+          <a:p>
+            <a:pPr algn="l" indent="0" marL="0">
+              <a:buNone/>
+            </a:pPr>
+            <a:r>
+              <a:rPr lang="en-US" sz="1900" b="1" dirty="0">
+                <a:solidFill>
+                  <a:srgbClr val="1A1A2E"/>
+                </a:solidFill>
+                <a:latin typeface="Caveat" pitchFamily="34" charset="0"/>
+                <a:ea typeface="Caveat" pitchFamily="34" charset="-122"/>
+                <a:cs typeface="Caveat" pitchFamily="34" charset="-120"/>
+              </a:rPr>
+              <a:t>More</a:t>
+            </a:r>
+            <a:endParaRPr lang="en-US" sz="1900" dirty="0"/>
+          </a:p>
+        </p:txBody>
+      </p:sp>
+      <p:sp>
+        <p:nvSpPr>
+          <p:cNvPr id="31" name="Text 29"/>
+          <p:cNvSpPr/>
+          <p:nvPr/>
+        </p:nvSpPr>
+        <p:spPr>
+          <a:xfrm rot="108000">
+            <a:off x="5917126" y="3866998"/>
+            <a:ext cx="918467" cy="484632"/>
+          </a:xfrm>
+          <a:prstGeom prst="rect">
+            <a:avLst/>
+          </a:prstGeom>
+          <a:noFill/>
+          <a:ln/>
+        </p:spPr>
+        <p:txBody>
+          <a:bodyPr wrap="square" lIns="0" tIns="0" rIns="0" bIns="0" rtlCol="0" anchor="b"/>
+          <a:lstStyle/>
+          <a:p>
+            <a:pPr algn="l" indent="0" marL="0">
+              <a:buNone/>
+            </a:pPr>
+            <a:r>
+              <a:rPr lang="en-US" sz="1900" b="1" dirty="0">
+                <a:solidFill>
+                  <a:srgbClr val="1A1A2E"/>
+                </a:solidFill>
+                <a:latin typeface="Caveat" pitchFamily="34" charset="0"/>
+                <a:ea typeface="Caveat" pitchFamily="34" charset="-122"/>
+                <a:cs typeface="Caveat" pitchFamily="34" charset="-120"/>
+              </a:rPr>
+              <a:t>particles</a:t>
+            </a:r>
+            <a:endParaRPr lang="en-US" sz="1900" dirty="0"/>
+          </a:p>
+        </p:txBody>
+      </p:sp>
+      <p:sp>
+        <p:nvSpPr>
+          <p:cNvPr id="32" name="Text 30"/>
+          <p:cNvSpPr/>
+          <p:nvPr/>
+        </p:nvSpPr>
+        <p:spPr>
+          <a:xfrm rot="-126000">
+            <a:off x="6707576" y="3899916"/>
+            <a:ext cx="367820" cy="484632"/>
+          </a:xfrm>
+          <a:prstGeom prst="rect">
+            <a:avLst/>
+          </a:prstGeom>
+          <a:noFill/>
+          <a:ln/>
+        </p:spPr>
+        <p:txBody>
+          <a:bodyPr wrap="square" lIns="0" tIns="0" rIns="0" bIns="0" rtlCol="0" anchor="b"/>
+          <a:lstStyle/>
+          <a:p>
+            <a:pPr algn="l" indent="0" marL="0">
+              <a:buNone/>
+            </a:pPr>
+            <a:r>
+              <a:rPr lang="en-US" sz="1900" b="1" dirty="0">
+                <a:solidFill>
+                  <a:srgbClr val="1A1A2E"/>
+                </a:solidFill>
+                <a:latin typeface="Caveat" pitchFamily="34" charset="0"/>
+                <a:ea typeface="Caveat" pitchFamily="34" charset="-122"/>
+                <a:cs typeface="Caveat" pitchFamily="34" charset="-120"/>
+              </a:rPr>
+              <a:t>in</a:t>
+            </a:r>
+            <a:endParaRPr lang="en-US" sz="1900" dirty="0"/>
+          </a:p>
+        </p:txBody>
+      </p:sp>
+      <p:sp>
+        <p:nvSpPr>
+          <p:cNvPr id="33" name="Text 31"/>
+          <p:cNvSpPr/>
+          <p:nvPr/>
+        </p:nvSpPr>
+        <p:spPr>
+          <a:xfrm rot="144000">
+            <a:off x="6947380" y="3869741"/>
+            <a:ext cx="484368" cy="484632"/>
+          </a:xfrm>
+          <a:prstGeom prst="rect">
+            <a:avLst/>
+          </a:prstGeom>
+          <a:noFill/>
+          <a:ln/>
+        </p:spPr>
+        <p:txBody>
+          <a:bodyPr wrap="square" lIns="0" tIns="0" rIns="0" bIns="0" rtlCol="0" anchor="b"/>
+          <a:lstStyle/>
+          <a:p>
+            <a:pPr algn="l" indent="0" marL="0">
+              <a:buNone/>
+            </a:pPr>
+            <a:r>
+              <a:rPr lang="en-US" sz="1900" b="1" dirty="0">
+                <a:solidFill>
+                  <a:srgbClr val="1A1A2E"/>
+                </a:solidFill>
+                <a:latin typeface="Caveat" pitchFamily="34" charset="0"/>
+                <a:ea typeface="Caveat" pitchFamily="34" charset="-122"/>
+                <a:cs typeface="Caveat" pitchFamily="34" charset="-120"/>
+              </a:rPr>
+              <a:t>the</a:t>
+            </a:r>
+            <a:endParaRPr lang="en-US" sz="1900" dirty="0"/>
+          </a:p>
+        </p:txBody>
+      </p:sp>
+      <p:sp>
+        <p:nvSpPr>
+          <p:cNvPr id="34" name="Text 32"/>
+          <p:cNvSpPr/>
+          <p:nvPr/>
+        </p:nvSpPr>
+        <p:spPr>
+          <a:xfrm rot="-90000">
+            <a:off x="7303732" y="3908146"/>
+            <a:ext cx="619737" cy="484632"/>
+          </a:xfrm>
+          <a:prstGeom prst="rect">
+            <a:avLst/>
+          </a:prstGeom>
+          <a:noFill/>
+          <a:ln/>
+        </p:spPr>
+        <p:txBody>
+          <a:bodyPr wrap="square" lIns="0" tIns="0" rIns="0" bIns="0" rtlCol="0" anchor="b"/>
+          <a:lstStyle/>
+          <a:p>
+            <a:pPr algn="l" indent="0" marL="0">
+              <a:buNone/>
+            </a:pPr>
+            <a:r>
+              <a:rPr lang="en-US" sz="1900" b="1" dirty="0">
+                <a:solidFill>
+                  <a:srgbClr val="1A1A2E"/>
+                </a:solidFill>
+                <a:latin typeface="Caveat" pitchFamily="34" charset="0"/>
+                <a:ea typeface="Caveat" pitchFamily="34" charset="-122"/>
+                <a:cs typeface="Caveat" pitchFamily="34" charset="-120"/>
+              </a:rPr>
+              <a:t>same</a:t>
+            </a:r>
+            <a:endParaRPr lang="en-US" sz="1900" dirty="0"/>
+          </a:p>
+        </p:txBody>
+      </p:sp>
+      <p:sp>
+        <p:nvSpPr>
+          <p:cNvPr id="35" name="Text 33"/>
+          <p:cNvSpPr/>
+          <p:nvPr/>
+        </p:nvSpPr>
+        <p:spPr>
+          <a:xfrm rot="126000">
+            <a:off x="7795453" y="3875227"/>
+            <a:ext cx="727116" cy="484632"/>
+          </a:xfrm>
+          <a:prstGeom prst="rect">
+            <a:avLst/>
+          </a:prstGeom>
+          <a:noFill/>
+          <a:ln/>
+        </p:spPr>
+        <p:txBody>
+          <a:bodyPr wrap="square" lIns="0" tIns="0" rIns="0" bIns="0" rtlCol="0" anchor="b"/>
+          <a:lstStyle/>
+          <a:p>
+            <a:pPr algn="l" indent="0" marL="0">
+              <a:buNone/>
+            </a:pPr>
+            <a:r>
+              <a:rPr lang="en-US" sz="1900" b="1" dirty="0">
+                <a:solidFill>
+                  <a:srgbClr val="1A1A2E"/>
+                </a:solidFill>
+                <a:latin typeface="Caveat" pitchFamily="34" charset="0"/>
+                <a:ea typeface="Caveat" pitchFamily="34" charset="-122"/>
+                <a:cs typeface="Caveat" pitchFamily="34" charset="-120"/>
+              </a:rPr>
+              <a:t>volume</a:t>
+            </a:r>
+            <a:endParaRPr lang="en-US" sz="1900" dirty="0"/>
+          </a:p>
+        </p:txBody>
+      </p:sp>
+      <p:sp>
+        <p:nvSpPr>
+          <p:cNvPr id="36" name="Text 34"/>
+          <p:cNvSpPr/>
+          <p:nvPr/>
+        </p:nvSpPr>
+        <p:spPr>
+          <a:xfrm rot="-144000">
+            <a:off x="8394553" y="3905402"/>
+            <a:ext cx="381574" cy="484632"/>
+          </a:xfrm>
+          <a:prstGeom prst="rect">
+            <a:avLst/>
+          </a:prstGeom>
+          <a:noFill/>
+          <a:ln/>
+        </p:spPr>
+        <p:txBody>
+          <a:bodyPr wrap="square" lIns="0" tIns="0" rIns="0" bIns="0" rtlCol="0" anchor="b"/>
+          <a:lstStyle/>
+          <a:p>
+            <a:pPr algn="l" indent="0" marL="0">
+              <a:buNone/>
+            </a:pPr>
+            <a:r>
+              <a:rPr lang="en-US" sz="1900" b="1" dirty="0">
+                <a:solidFill>
+                  <a:srgbClr val="1A1A2E"/>
+                </a:solidFill>
+                <a:latin typeface="Caveat" pitchFamily="34" charset="0"/>
+                <a:ea typeface="Caveat" pitchFamily="34" charset="-122"/>
+                <a:cs typeface="Caveat" pitchFamily="34" charset="-120"/>
+              </a:rPr>
+              <a:t>so</a:t>
+            </a:r>
+            <a:endParaRPr lang="en-US" sz="1900" dirty="0"/>
+          </a:p>
+        </p:txBody>
+      </p:sp>
+      <p:sp>
+        <p:nvSpPr>
+          <p:cNvPr id="37" name="Text 35"/>
+          <p:cNvSpPr/>
+          <p:nvPr/>
+        </p:nvSpPr>
+        <p:spPr>
+          <a:xfrm rot="72000">
+            <a:off x="8648111" y="3872484"/>
+            <a:ext cx="566651" cy="484632"/>
+          </a:xfrm>
+          <a:prstGeom prst="rect">
+            <a:avLst/>
+          </a:prstGeom>
+          <a:noFill/>
+          <a:ln/>
+        </p:spPr>
+        <p:txBody>
+          <a:bodyPr wrap="square" lIns="0" tIns="0" rIns="0" bIns="0" rtlCol="0" anchor="b"/>
+          <a:lstStyle/>
+          <a:p>
+            <a:pPr algn="l" indent="0" marL="0">
+              <a:buNone/>
+            </a:pPr>
+            <a:r>
+              <a:rPr lang="en-US" sz="1900" b="1" dirty="0">
+                <a:solidFill>
+                  <a:srgbClr val="1A1A2E"/>
+                </a:solidFill>
+                <a:latin typeface="Caveat" pitchFamily="34" charset="0"/>
+                <a:ea typeface="Caveat" pitchFamily="34" charset="-122"/>
+                <a:cs typeface="Caveat" pitchFamily="34" charset="-120"/>
+              </a:rPr>
+              <a:t>they</a:t>
+            </a:r>
+            <a:endParaRPr lang="en-US" sz="1900" dirty="0"/>
+          </a:p>
+        </p:txBody>
+      </p:sp>
+      <p:sp>
+        <p:nvSpPr>
+          <p:cNvPr id="38" name="Text 36"/>
+          <p:cNvSpPr/>
+          <p:nvPr/>
+        </p:nvSpPr>
+        <p:spPr>
+          <a:xfrm rot="-162000">
+            <a:off x="9086746" y="3902659"/>
+            <a:ext cx="484850" cy="484632"/>
+          </a:xfrm>
+          <a:prstGeom prst="rect">
+            <a:avLst/>
+          </a:prstGeom>
+          <a:noFill/>
+          <a:ln/>
+        </p:spPr>
+        <p:txBody>
+          <a:bodyPr wrap="square" lIns="0" tIns="0" rIns="0" bIns="0" rtlCol="0" anchor="b"/>
+          <a:lstStyle/>
+          <a:p>
+            <a:pPr algn="l" indent="0" marL="0">
+              <a:buNone/>
+            </a:pPr>
+            <a:r>
+              <a:rPr lang="en-US" sz="1900" b="1" dirty="0">
+                <a:solidFill>
+                  <a:srgbClr val="1A1A2E"/>
+                </a:solidFill>
+                <a:latin typeface="Caveat" pitchFamily="34" charset="0"/>
+                <a:ea typeface="Caveat" pitchFamily="34" charset="-122"/>
+                <a:cs typeface="Caveat" pitchFamily="34" charset="-120"/>
+              </a:rPr>
+              <a:t>are</a:t>
+            </a:r>
+            <a:endParaRPr lang="en-US" sz="1900" dirty="0"/>
+          </a:p>
+        </p:txBody>
+      </p:sp>
+      <p:sp>
+        <p:nvSpPr>
+          <p:cNvPr id="39" name="Text 37"/>
+          <p:cNvSpPr/>
+          <p:nvPr/>
+        </p:nvSpPr>
+        <p:spPr>
+          <a:xfrm rot="108000">
+            <a:off x="9443580" y="3866998"/>
+            <a:ext cx="727598" cy="484632"/>
+          </a:xfrm>
+          <a:prstGeom prst="rect">
+            <a:avLst/>
+          </a:prstGeom>
+          <a:noFill/>
+          <a:ln/>
+        </p:spPr>
+        <p:txBody>
+          <a:bodyPr wrap="square" lIns="0" tIns="0" rIns="0" bIns="0" rtlCol="0" anchor="b"/>
+          <a:lstStyle/>
+          <a:p>
+            <a:pPr algn="l" indent="0" marL="0">
+              <a:buNone/>
+            </a:pPr>
+            <a:r>
+              <a:rPr lang="en-US" sz="1900" b="1" dirty="0">
+                <a:solidFill>
+                  <a:srgbClr val="1A1A2E"/>
+                </a:solidFill>
+                <a:latin typeface="Caveat" pitchFamily="34" charset="0"/>
+                <a:ea typeface="Caveat" pitchFamily="34" charset="-122"/>
+                <a:cs typeface="Caveat" pitchFamily="34" charset="-120"/>
+              </a:rPr>
+              <a:t>closer.</a:t>
+            </a:r>
+            <a:endParaRPr lang="en-US" sz="1900" dirty="0"/>
+          </a:p>
+        </p:txBody>
+      </p:sp>
+      <p:sp>
+        <p:nvSpPr>
+          <p:cNvPr id="40" name="Text 38"/>
+          <p:cNvSpPr/>
+          <p:nvPr/>
+        </p:nvSpPr>
+        <p:spPr>
+          <a:xfrm rot="-126000">
+            <a:off x="10043163" y="3899916"/>
+            <a:ext cx="621909" cy="484632"/>
+          </a:xfrm>
+          <a:prstGeom prst="rect">
+            <a:avLst/>
+          </a:prstGeom>
+          <a:noFill/>
+          <a:ln/>
+        </p:spPr>
+        <p:txBody>
+          <a:bodyPr wrap="square" lIns="0" tIns="0" rIns="0" bIns="0" rtlCol="0" anchor="b"/>
+          <a:lstStyle/>
+          <a:p>
+            <a:pPr algn="l" indent="0" marL="0">
+              <a:buNone/>
+            </a:pPr>
+            <a:r>
+              <a:rPr lang="en-US" sz="1900" b="1" dirty="0">
+                <a:solidFill>
+                  <a:srgbClr val="1A1A2E"/>
+                </a:solidFill>
+                <a:latin typeface="Caveat" pitchFamily="34" charset="0"/>
+                <a:ea typeface="Caveat" pitchFamily="34" charset="-122"/>
+                <a:cs typeface="Caveat" pitchFamily="34" charset="-120"/>
+              </a:rPr>
+              <a:t>That</a:t>
+            </a:r>
+            <a:endParaRPr lang="en-US" sz="1900" dirty="0"/>
+          </a:p>
+        </p:txBody>
+      </p:sp>
+      <p:sp>
+        <p:nvSpPr>
+          <p:cNvPr id="41" name="Text 39"/>
+          <p:cNvSpPr/>
+          <p:nvPr/>
+        </p:nvSpPr>
+        <p:spPr>
+          <a:xfrm rot="144000">
+            <a:off x="10537055" y="3869741"/>
+            <a:ext cx="730494" cy="484632"/>
+          </a:xfrm>
+          <a:prstGeom prst="rect">
+            <a:avLst/>
+          </a:prstGeom>
+          <a:noFill/>
+          <a:ln/>
+        </p:spPr>
+        <p:txBody>
+          <a:bodyPr wrap="square" lIns="0" tIns="0" rIns="0" bIns="0" rtlCol="0" anchor="b"/>
+          <a:lstStyle/>
+          <a:p>
+            <a:pPr algn="l" indent="0" marL="0">
+              <a:buNone/>
+            </a:pPr>
+            <a:r>
+              <a:rPr lang="en-US" sz="1900" b="1" dirty="0">
+                <a:solidFill>
+                  <a:srgbClr val="1A1A2E"/>
+                </a:solidFill>
+                <a:latin typeface="Caveat" pitchFamily="34" charset="0"/>
+                <a:ea typeface="Caveat" pitchFamily="34" charset="-122"/>
+                <a:cs typeface="Caveat" pitchFamily="34" charset="-120"/>
+              </a:rPr>
+              <a:t>means</a:t>
+            </a:r>
+            <a:endParaRPr lang="en-US" sz="1900" dirty="0"/>
+          </a:p>
+        </p:txBody>
+      </p:sp>
+      <p:sp>
+        <p:nvSpPr>
+          <p:cNvPr id="42" name="Text 40"/>
+          <p:cNvSpPr/>
+          <p:nvPr/>
+        </p:nvSpPr>
+        <p:spPr>
+          <a:xfrm rot="-90000">
+            <a:off x="11139533" y="3908146"/>
+            <a:ext cx="601881" cy="484632"/>
+          </a:xfrm>
+          <a:prstGeom prst="rect">
+            <a:avLst/>
+          </a:prstGeom>
+          <a:noFill/>
+          <a:ln/>
+        </p:spPr>
+        <p:txBody>
+          <a:bodyPr wrap="square" lIns="0" tIns="0" rIns="0" bIns="0" rtlCol="0" anchor="b"/>
+          <a:lstStyle/>
+          <a:p>
+            <a:pPr algn="l" indent="0" marL="0">
+              <a:buNone/>
+            </a:pPr>
+            <a:r>
+              <a:rPr lang="en-US" sz="1900" b="1" dirty="0">
+                <a:solidFill>
+                  <a:srgbClr val="1A1A2E"/>
+                </a:solidFill>
+                <a:latin typeface="Caveat" pitchFamily="34" charset="0"/>
+                <a:ea typeface="Caveat" pitchFamily="34" charset="-122"/>
+                <a:cs typeface="Caveat" pitchFamily="34" charset="-120"/>
+              </a:rPr>
+              <a:t>more</a:t>
+            </a:r>
+            <a:endParaRPr lang="en-US" sz="1900" dirty="0"/>
+          </a:p>
+        </p:txBody>
+      </p:sp>
+      <p:sp>
+        <p:nvSpPr>
+          <p:cNvPr id="43" name="Text 41"/>
+          <p:cNvSpPr/>
+          <p:nvPr/>
+        </p:nvSpPr>
+        <p:spPr>
+          <a:xfrm rot="126000">
+            <a:off x="5404653" y="4359859"/>
+            <a:ext cx="932462" cy="484632"/>
+          </a:xfrm>
+          <a:prstGeom prst="rect">
+            <a:avLst/>
+          </a:prstGeom>
+          <a:noFill/>
+          <a:ln/>
+        </p:spPr>
+        <p:txBody>
+          <a:bodyPr wrap="square" lIns="0" tIns="0" rIns="0" bIns="0" rtlCol="0" anchor="b"/>
+          <a:lstStyle/>
+          <a:p>
+            <a:pPr algn="l" indent="0" marL="0">
+              <a:buNone/>
+            </a:pPr>
+            <a:r>
+              <a:rPr lang="en-US" sz="1900" b="1" dirty="0">
+                <a:solidFill>
+                  <a:srgbClr val="1A1A2E"/>
+                </a:solidFill>
+                <a:latin typeface="Caveat" pitchFamily="34" charset="0"/>
+                <a:ea typeface="Caveat" pitchFamily="34" charset="-122"/>
+                <a:cs typeface="Caveat" pitchFamily="34" charset="-120"/>
+              </a:rPr>
+              <a:t>collisions</a:t>
+            </a:r>
+            <a:endParaRPr lang="en-US" sz="1900" dirty="0"/>
+          </a:p>
+        </p:txBody>
+      </p:sp>
+      <p:sp>
+        <p:nvSpPr>
+          <p:cNvPr id="44" name="Text 42"/>
+          <p:cNvSpPr/>
+          <p:nvPr/>
+        </p:nvSpPr>
+        <p:spPr>
+          <a:xfrm rot="-144000">
+            <a:off x="6209099" y="4390034"/>
+            <a:ext cx="381574" cy="484632"/>
+          </a:xfrm>
+          <a:prstGeom prst="rect">
+            <a:avLst/>
+          </a:prstGeom>
+          <a:noFill/>
+          <a:ln/>
+        </p:spPr>
+        <p:txBody>
+          <a:bodyPr wrap="square" lIns="0" tIns="0" rIns="0" bIns="0" rtlCol="0" anchor="b"/>
+          <a:lstStyle/>
+          <a:p>
+            <a:pPr algn="l" indent="0" marL="0">
+              <a:buNone/>
+            </a:pPr>
+            <a:r>
+              <a:rPr lang="en-US" sz="1900" b="1" dirty="0">
+                <a:solidFill>
+                  <a:srgbClr val="1A1A2E"/>
+                </a:solidFill>
+                <a:latin typeface="Caveat" pitchFamily="34" charset="0"/>
+                <a:ea typeface="Caveat" pitchFamily="34" charset="-122"/>
+                <a:cs typeface="Caveat" pitchFamily="34" charset="-120"/>
+              </a:rPr>
+              <a:t>so</a:t>
+            </a:r>
+            <a:endParaRPr lang="en-US" sz="1900" dirty="0"/>
+          </a:p>
+        </p:txBody>
+      </p:sp>
+      <p:sp>
+        <p:nvSpPr>
+          <p:cNvPr id="45" name="Text 43"/>
+          <p:cNvSpPr/>
+          <p:nvPr/>
+        </p:nvSpPr>
+        <p:spPr>
+          <a:xfrm rot="72000">
+            <a:off x="6462657" y="4357116"/>
+            <a:ext cx="484368" cy="484632"/>
+          </a:xfrm>
+          <a:prstGeom prst="rect">
+            <a:avLst/>
+          </a:prstGeom>
+          <a:noFill/>
+          <a:ln/>
+        </p:spPr>
+        <p:txBody>
+          <a:bodyPr wrap="square" lIns="0" tIns="0" rIns="0" bIns="0" rtlCol="0" anchor="b"/>
+          <a:lstStyle/>
+          <a:p>
+            <a:pPr algn="l" indent="0" marL="0">
+              <a:buNone/>
+            </a:pPr>
+            <a:r>
+              <a:rPr lang="en-US" sz="1900" b="1" dirty="0">
+                <a:solidFill>
+                  <a:srgbClr val="1A1A2E"/>
+                </a:solidFill>
+                <a:latin typeface="Caveat" pitchFamily="34" charset="0"/>
+                <a:ea typeface="Caveat" pitchFamily="34" charset="-122"/>
+                <a:cs typeface="Caveat" pitchFamily="34" charset="-120"/>
+              </a:rPr>
+              <a:t>the</a:t>
+            </a:r>
+            <a:endParaRPr lang="en-US" sz="1900" dirty="0"/>
+          </a:p>
+        </p:txBody>
+      </p:sp>
+      <p:sp>
+        <p:nvSpPr>
+          <p:cNvPr id="46" name="Text 44"/>
+          <p:cNvSpPr/>
+          <p:nvPr/>
+        </p:nvSpPr>
+        <p:spPr>
+          <a:xfrm rot="-162000">
+            <a:off x="6819008" y="4387291"/>
+            <a:ext cx="564721" cy="484632"/>
+          </a:xfrm>
+          <a:prstGeom prst="rect">
+            <a:avLst/>
+          </a:prstGeom>
+          <a:noFill/>
+          <a:ln/>
+        </p:spPr>
+        <p:txBody>
+          <a:bodyPr wrap="square" lIns="0" tIns="0" rIns="0" bIns="0" rtlCol="0" anchor="b"/>
+          <a:lstStyle/>
+          <a:p>
+            <a:pPr algn="l" indent="0" marL="0">
+              <a:buNone/>
+            </a:pPr>
+            <a:r>
+              <a:rPr lang="en-US" sz="1900" b="1" dirty="0">
+                <a:solidFill>
+                  <a:srgbClr val="1A1A2E"/>
+                </a:solidFill>
+                <a:latin typeface="Caveat" pitchFamily="34" charset="0"/>
+                <a:ea typeface="Caveat" pitchFamily="34" charset="-122"/>
+                <a:cs typeface="Caveat" pitchFamily="34" charset="-120"/>
+              </a:rPr>
+              <a:t>rate</a:t>
+            </a:r>
+            <a:endParaRPr lang="en-US" sz="1900" dirty="0"/>
+          </a:p>
+        </p:txBody>
+      </p:sp>
+      <p:sp>
+        <p:nvSpPr>
+          <p:cNvPr id="47" name="Text 45"/>
+          <p:cNvSpPr/>
+          <p:nvPr/>
+        </p:nvSpPr>
+        <p:spPr>
+          <a:xfrm rot="108000">
+            <a:off x="7255713" y="4351630"/>
+            <a:ext cx="550001" cy="484632"/>
+          </a:xfrm>
+          <a:prstGeom prst="rect">
+            <a:avLst/>
+          </a:prstGeom>
+          <a:noFill/>
+          <a:ln/>
+        </p:spPr>
+        <p:txBody>
+          <a:bodyPr wrap="square" lIns="0" tIns="0" rIns="0" bIns="0" rtlCol="0" anchor="b"/>
+          <a:lstStyle/>
+          <a:p>
+            <a:pPr algn="l" indent="0" marL="0">
+              <a:buNone/>
+            </a:pPr>
+            <a:r>
+              <a:rPr lang="en-US" sz="1900" b="1" dirty="0">
+                <a:solidFill>
+                  <a:srgbClr val="1A1A2E"/>
+                </a:solidFill>
+                <a:latin typeface="Caveat" pitchFamily="34" charset="0"/>
+                <a:ea typeface="Caveat" pitchFamily="34" charset="-122"/>
+                <a:cs typeface="Caveat" pitchFamily="34" charset="-120"/>
+              </a:rPr>
+              <a:t>goes</a:t>
+            </a:r>
+            <a:endParaRPr lang="en-US" sz="1900" dirty="0"/>
+          </a:p>
+        </p:txBody>
+      </p:sp>
+      <p:sp>
+        <p:nvSpPr>
+          <p:cNvPr id="48" name="Text 46"/>
+          <p:cNvSpPr/>
+          <p:nvPr/>
+        </p:nvSpPr>
+        <p:spPr>
+          <a:xfrm rot="-126000">
+            <a:off x="7677699" y="4384548"/>
+            <a:ext cx="438038" cy="484632"/>
+          </a:xfrm>
+          <a:prstGeom prst="rect">
+            <a:avLst/>
+          </a:prstGeom>
+          <a:noFill/>
+          <a:ln/>
+        </p:spPr>
+        <p:txBody>
+          <a:bodyPr wrap="square" lIns="0" tIns="0" rIns="0" bIns="0" rtlCol="0" anchor="b"/>
+          <a:lstStyle/>
+          <a:p>
+            <a:pPr algn="l" indent="0" marL="0">
+              <a:buNone/>
+            </a:pPr>
+            <a:r>
+              <a:rPr lang="en-US" sz="1900" b="1" dirty="0">
+                <a:solidFill>
+                  <a:srgbClr val="1A1A2E"/>
+                </a:solidFill>
+                <a:latin typeface="Caveat" pitchFamily="34" charset="0"/>
+                <a:ea typeface="Caveat" pitchFamily="34" charset="-122"/>
+                <a:cs typeface="Caveat" pitchFamily="34" charset="-120"/>
+              </a:rPr>
+              <a:t>up.</a:t>
+            </a:r>
+            <a:endParaRPr lang="en-US" sz="1900" dirty="0"/>
+          </a:p>
+        </p:txBody>
+      </p:sp>
+      <p:sp>
+        <p:nvSpPr>
+          <p:cNvPr id="49" name="Shape 47"/>
+          <p:cNvSpPr/>
+          <p:nvPr/>
+        </p:nvSpPr>
+        <p:spPr>
+          <a:xfrm>
+            <a:off x="5404653" y="4370832"/>
             <a:ext cx="6199083" cy="0"/>
           </a:xfrm>
           <a:prstGeom prst="line">
@@ -17092,820 +17883,13 @@
       </p:sp>
       <p:sp>
         <p:nvSpPr>
-          <p:cNvPr id="29" name="Text 27"/>
-          <p:cNvSpPr/>
-          <p:nvPr/>
-        </p:nvSpPr>
-        <p:spPr>
-          <a:xfrm>
-            <a:off x="5276637" y="3538728"/>
-            <a:ext cx="6500835" cy="237744"/>
-          </a:xfrm>
-          <a:prstGeom prst="rect">
-            <a:avLst/>
-          </a:prstGeom>
-          <a:solidFill>
-            <a:srgbClr val="0D1B5E"/>
-          </a:solidFill>
-          <a:ln/>
-        </p:spPr>
-        <p:txBody>
-          <a:bodyPr wrap="square" lIns="76200" tIns="76200" rIns="76200" bIns="76200" rtlCol="0" anchor="ctr"/>
-          <a:lstStyle/>
-          <a:p>
-            <a:pPr algn="l" indent="0" marL="0">
-              <a:buNone/>
-            </a:pPr>
-            <a:r>
-              <a:rPr lang="en-US" sz="1200" b="1" dirty="0">
-                <a:solidFill>
-                  <a:srgbClr val="FABB2E"/>
-                </a:solidFill>
-                <a:latin typeface="Trebuchet MS" pitchFamily="34" charset="0"/>
-                <a:ea typeface="Trebuchet MS" pitchFamily="34" charset="-122"/>
-                <a:cs typeface="Trebuchet MS" pitchFamily="34" charset="-120"/>
-              </a:rPr>
-              <a:t>Student B</a:t>
-            </a:r>
-            <a:endParaRPr lang="en-US" sz="1200" dirty="0"/>
-          </a:p>
-        </p:txBody>
-      </p:sp>
-      <p:sp>
-        <p:nvSpPr>
-          <p:cNvPr id="30" name="Shape 28"/>
-          <p:cNvSpPr/>
-          <p:nvPr/>
-        </p:nvSpPr>
-        <p:spPr>
-          <a:xfrm>
-            <a:off x="5276637" y="3776472"/>
-            <a:ext cx="6500835" cy="1188720"/>
-          </a:xfrm>
-          <a:prstGeom prst="rect">
-            <a:avLst/>
-          </a:prstGeom>
-          <a:solidFill>
-            <a:srgbClr val="FFFFFF"/>
-          </a:solidFill>
-          <a:ln w="25400">
-            <a:solidFill>
-              <a:srgbClr val="FABB2E"/>
-            </a:solidFill>
-            <a:prstDash val="solid"/>
-          </a:ln>
-        </p:spPr>
-      </p:sp>
-      <p:sp>
-        <p:nvSpPr>
-          <p:cNvPr id="31" name="Text 29"/>
-          <p:cNvSpPr/>
-          <p:nvPr/>
-        </p:nvSpPr>
-        <p:spPr>
-          <a:xfrm rot="-162000">
-            <a:off x="5404653" y="3902659"/>
-            <a:ext cx="868680" cy="374015"/>
-          </a:xfrm>
-          <a:prstGeom prst="rect">
-            <a:avLst/>
-          </a:prstGeom>
-          <a:noFill/>
-          <a:ln/>
-        </p:spPr>
-        <p:txBody>
-          <a:bodyPr wrap="square" lIns="0" tIns="0" rIns="0" bIns="0" rtlCol="0" anchor="b"/>
-          <a:lstStyle/>
-          <a:p>
-            <a:pPr algn="l" indent="0" marL="0">
-              <a:buNone/>
-            </a:pPr>
-            <a:r>
-              <a:rPr lang="en-US" sz="1900" b="1" dirty="0">
-                <a:solidFill>
-                  <a:srgbClr val="1A1A2E"/>
-                </a:solidFill>
-                <a:latin typeface="Caveat" pitchFamily="34" charset="0"/>
-                <a:ea typeface="Caveat" pitchFamily="34" charset="-122"/>
-                <a:cs typeface="Caveat" pitchFamily="34" charset="-120"/>
-              </a:rPr>
-              <a:t>More</a:t>
-            </a:r>
-            <a:endParaRPr lang="en-US" sz="1900" dirty="0"/>
-          </a:p>
-        </p:txBody>
-      </p:sp>
-      <p:sp>
-        <p:nvSpPr>
-          <p:cNvPr id="32" name="Text 30"/>
-          <p:cNvSpPr/>
-          <p:nvPr/>
-        </p:nvSpPr>
-        <p:spPr>
-          <a:xfrm rot="108000">
-            <a:off x="6145317" y="3866998"/>
-            <a:ext cx="1737360" cy="374015"/>
-          </a:xfrm>
-          <a:prstGeom prst="rect">
-            <a:avLst/>
-          </a:prstGeom>
-          <a:noFill/>
-          <a:ln/>
-        </p:spPr>
-        <p:txBody>
-          <a:bodyPr wrap="square" lIns="0" tIns="0" rIns="0" bIns="0" rtlCol="0" anchor="b"/>
-          <a:lstStyle/>
-          <a:p>
-            <a:pPr algn="l" indent="0" marL="0">
-              <a:buNone/>
-            </a:pPr>
-            <a:r>
-              <a:rPr lang="en-US" sz="1900" b="1" dirty="0">
-                <a:solidFill>
-                  <a:srgbClr val="1A1A2E"/>
-                </a:solidFill>
-                <a:latin typeface="Caveat" pitchFamily="34" charset="0"/>
-                <a:ea typeface="Caveat" pitchFamily="34" charset="-122"/>
-                <a:cs typeface="Caveat" pitchFamily="34" charset="-120"/>
-              </a:rPr>
-              <a:t>particles</a:t>
-            </a:r>
-            <a:endParaRPr lang="en-US" sz="1900" dirty="0"/>
-          </a:p>
-        </p:txBody>
-      </p:sp>
-      <p:sp>
-        <p:nvSpPr>
-          <p:cNvPr id="33" name="Text 31"/>
-          <p:cNvSpPr/>
-          <p:nvPr/>
-        </p:nvSpPr>
-        <p:spPr>
-          <a:xfrm rot="-126000">
-            <a:off x="7754661" y="3899916"/>
-            <a:ext cx="521208" cy="374015"/>
-          </a:xfrm>
-          <a:prstGeom prst="rect">
-            <a:avLst/>
-          </a:prstGeom>
-          <a:noFill/>
-          <a:ln/>
-        </p:spPr>
-        <p:txBody>
-          <a:bodyPr wrap="square" lIns="0" tIns="0" rIns="0" bIns="0" rtlCol="0" anchor="b"/>
-          <a:lstStyle/>
-          <a:p>
-            <a:pPr algn="l" indent="0" marL="0">
-              <a:buNone/>
-            </a:pPr>
-            <a:r>
-              <a:rPr lang="en-US" sz="1900" b="1" dirty="0">
-                <a:solidFill>
-                  <a:srgbClr val="1A1A2E"/>
-                </a:solidFill>
-                <a:latin typeface="Caveat" pitchFamily="34" charset="0"/>
-                <a:ea typeface="Caveat" pitchFamily="34" charset="-122"/>
-                <a:cs typeface="Caveat" pitchFamily="34" charset="-120"/>
-              </a:rPr>
-              <a:t>in</a:t>
-            </a:r>
-            <a:endParaRPr lang="en-US" sz="1900" dirty="0"/>
-          </a:p>
-        </p:txBody>
-      </p:sp>
-      <p:sp>
-        <p:nvSpPr>
-          <p:cNvPr id="34" name="Text 32"/>
-          <p:cNvSpPr/>
-          <p:nvPr/>
-        </p:nvSpPr>
-        <p:spPr>
-          <a:xfrm rot="144000">
-            <a:off x="8147853" y="3869741"/>
-            <a:ext cx="694944" cy="374015"/>
-          </a:xfrm>
-          <a:prstGeom prst="rect">
-            <a:avLst/>
-          </a:prstGeom>
-          <a:noFill/>
-          <a:ln/>
-        </p:spPr>
-        <p:txBody>
-          <a:bodyPr wrap="square" lIns="0" tIns="0" rIns="0" bIns="0" rtlCol="0" anchor="b"/>
-          <a:lstStyle/>
-          <a:p>
-            <a:pPr algn="l" indent="0" marL="0">
-              <a:buNone/>
-            </a:pPr>
-            <a:r>
-              <a:rPr lang="en-US" sz="1900" b="1" dirty="0">
-                <a:solidFill>
-                  <a:srgbClr val="1A1A2E"/>
-                </a:solidFill>
-                <a:latin typeface="Caveat" pitchFamily="34" charset="0"/>
-                <a:ea typeface="Caveat" pitchFamily="34" charset="-122"/>
-                <a:cs typeface="Caveat" pitchFamily="34" charset="-120"/>
-              </a:rPr>
-              <a:t>the</a:t>
-            </a:r>
-            <a:endParaRPr lang="en-US" sz="1900" dirty="0"/>
-          </a:p>
-        </p:txBody>
-      </p:sp>
-      <p:sp>
-        <p:nvSpPr>
-          <p:cNvPr id="35" name="Text 33"/>
-          <p:cNvSpPr/>
-          <p:nvPr/>
-        </p:nvSpPr>
-        <p:spPr>
-          <a:xfrm rot="-90000">
-            <a:off x="8714781" y="3908146"/>
-            <a:ext cx="868680" cy="374015"/>
-          </a:xfrm>
-          <a:prstGeom prst="rect">
-            <a:avLst/>
-          </a:prstGeom>
-          <a:noFill/>
-          <a:ln/>
-        </p:spPr>
-        <p:txBody>
-          <a:bodyPr wrap="square" lIns="0" tIns="0" rIns="0" bIns="0" rtlCol="0" anchor="b"/>
-          <a:lstStyle/>
-          <a:p>
-            <a:pPr algn="l" indent="0" marL="0">
-              <a:buNone/>
-            </a:pPr>
-            <a:r>
-              <a:rPr lang="en-US" sz="1900" b="1" dirty="0">
-                <a:solidFill>
-                  <a:srgbClr val="1A1A2E"/>
-                </a:solidFill>
-                <a:latin typeface="Caveat" pitchFamily="34" charset="0"/>
-                <a:ea typeface="Caveat" pitchFamily="34" charset="-122"/>
-                <a:cs typeface="Caveat" pitchFamily="34" charset="-120"/>
-              </a:rPr>
-              <a:t>same</a:t>
-            </a:r>
-            <a:endParaRPr lang="en-US" sz="1900" dirty="0"/>
-          </a:p>
-        </p:txBody>
-      </p:sp>
-      <p:sp>
-        <p:nvSpPr>
-          <p:cNvPr id="36" name="Text 34"/>
-          <p:cNvSpPr/>
-          <p:nvPr/>
-        </p:nvSpPr>
-        <p:spPr>
-          <a:xfrm rot="126000">
-            <a:off x="9455445" y="3875227"/>
-            <a:ext cx="1216152" cy="374015"/>
-          </a:xfrm>
-          <a:prstGeom prst="rect">
-            <a:avLst/>
-          </a:prstGeom>
-          <a:noFill/>
-          <a:ln/>
-        </p:spPr>
-        <p:txBody>
-          <a:bodyPr wrap="square" lIns="0" tIns="0" rIns="0" bIns="0" rtlCol="0" anchor="b"/>
-          <a:lstStyle/>
-          <a:p>
-            <a:pPr algn="l" indent="0" marL="0">
-              <a:buNone/>
-            </a:pPr>
-            <a:r>
-              <a:rPr lang="en-US" sz="1900" b="1" dirty="0">
-                <a:solidFill>
-                  <a:srgbClr val="1A1A2E"/>
-                </a:solidFill>
-                <a:latin typeface="Caveat" pitchFamily="34" charset="0"/>
-                <a:ea typeface="Caveat" pitchFamily="34" charset="-122"/>
-                <a:cs typeface="Caveat" pitchFamily="34" charset="-120"/>
-              </a:rPr>
-              <a:t>volume</a:t>
-            </a:r>
-            <a:endParaRPr lang="en-US" sz="1900" dirty="0"/>
-          </a:p>
-        </p:txBody>
-      </p:sp>
-      <p:sp>
-        <p:nvSpPr>
-          <p:cNvPr id="37" name="Text 35"/>
-          <p:cNvSpPr/>
-          <p:nvPr/>
-        </p:nvSpPr>
-        <p:spPr>
-          <a:xfrm rot="-144000">
-            <a:off x="10543581" y="3905402"/>
-            <a:ext cx="521208" cy="374015"/>
-          </a:xfrm>
-          <a:prstGeom prst="rect">
-            <a:avLst/>
-          </a:prstGeom>
-          <a:noFill/>
-          <a:ln/>
-        </p:spPr>
-        <p:txBody>
-          <a:bodyPr wrap="square" lIns="0" tIns="0" rIns="0" bIns="0" rtlCol="0" anchor="b"/>
-          <a:lstStyle/>
-          <a:p>
-            <a:pPr algn="l" indent="0" marL="0">
-              <a:buNone/>
-            </a:pPr>
-            <a:r>
-              <a:rPr lang="en-US" sz="1900" b="1" dirty="0">
-                <a:solidFill>
-                  <a:srgbClr val="1A1A2E"/>
-                </a:solidFill>
-                <a:latin typeface="Caveat" pitchFamily="34" charset="0"/>
-                <a:ea typeface="Caveat" pitchFamily="34" charset="-122"/>
-                <a:cs typeface="Caveat" pitchFamily="34" charset="-120"/>
-              </a:rPr>
-              <a:t>so</a:t>
-            </a:r>
-            <a:endParaRPr lang="en-US" sz="1900" dirty="0"/>
-          </a:p>
-        </p:txBody>
-      </p:sp>
-      <p:sp>
-        <p:nvSpPr>
-          <p:cNvPr id="38" name="Text 36"/>
-          <p:cNvSpPr/>
-          <p:nvPr/>
-        </p:nvSpPr>
-        <p:spPr>
-          <a:xfrm rot="72000">
-            <a:off x="5404653" y="4246499"/>
-            <a:ext cx="868680" cy="374015"/>
-          </a:xfrm>
-          <a:prstGeom prst="rect">
-            <a:avLst/>
-          </a:prstGeom>
-          <a:noFill/>
-          <a:ln/>
-        </p:spPr>
-        <p:txBody>
-          <a:bodyPr wrap="square" lIns="0" tIns="0" rIns="0" bIns="0" rtlCol="0" anchor="b"/>
-          <a:lstStyle/>
-          <a:p>
-            <a:pPr algn="l" indent="0" marL="0">
-              <a:buNone/>
-            </a:pPr>
-            <a:r>
-              <a:rPr lang="en-US" sz="1900" b="1" dirty="0">
-                <a:solidFill>
-                  <a:srgbClr val="1A1A2E"/>
-                </a:solidFill>
-                <a:latin typeface="Caveat" pitchFamily="34" charset="0"/>
-                <a:ea typeface="Caveat" pitchFamily="34" charset="-122"/>
-                <a:cs typeface="Caveat" pitchFamily="34" charset="-120"/>
-              </a:rPr>
-              <a:t>they</a:t>
-            </a:r>
-            <a:endParaRPr lang="en-US" sz="1900" dirty="0"/>
-          </a:p>
-        </p:txBody>
-      </p:sp>
-      <p:sp>
-        <p:nvSpPr>
-          <p:cNvPr id="39" name="Text 37"/>
-          <p:cNvSpPr/>
-          <p:nvPr/>
-        </p:nvSpPr>
-        <p:spPr>
-          <a:xfrm rot="-162000">
-            <a:off x="6145317" y="4276674"/>
-            <a:ext cx="694944" cy="374015"/>
-          </a:xfrm>
-          <a:prstGeom prst="rect">
-            <a:avLst/>
-          </a:prstGeom>
-          <a:noFill/>
-          <a:ln/>
-        </p:spPr>
-        <p:txBody>
-          <a:bodyPr wrap="square" lIns="0" tIns="0" rIns="0" bIns="0" rtlCol="0" anchor="b"/>
-          <a:lstStyle/>
-          <a:p>
-            <a:pPr algn="l" indent="0" marL="0">
-              <a:buNone/>
-            </a:pPr>
-            <a:r>
-              <a:rPr lang="en-US" sz="1900" b="1" dirty="0">
-                <a:solidFill>
-                  <a:srgbClr val="1A1A2E"/>
-                </a:solidFill>
-                <a:latin typeface="Caveat" pitchFamily="34" charset="0"/>
-                <a:ea typeface="Caveat" pitchFamily="34" charset="-122"/>
-                <a:cs typeface="Caveat" pitchFamily="34" charset="-120"/>
-              </a:rPr>
-              <a:t>are</a:t>
-            </a:r>
-            <a:endParaRPr lang="en-US" sz="1900" dirty="0"/>
-          </a:p>
-        </p:txBody>
-      </p:sp>
-      <p:sp>
-        <p:nvSpPr>
-          <p:cNvPr id="40" name="Text 38"/>
-          <p:cNvSpPr/>
-          <p:nvPr/>
-        </p:nvSpPr>
-        <p:spPr>
-          <a:xfrm rot="108000">
-            <a:off x="6712245" y="4241013"/>
-            <a:ext cx="1389888" cy="374015"/>
-          </a:xfrm>
-          <a:prstGeom prst="rect">
-            <a:avLst/>
-          </a:prstGeom>
-          <a:noFill/>
-          <a:ln/>
-        </p:spPr>
-        <p:txBody>
-          <a:bodyPr wrap="square" lIns="0" tIns="0" rIns="0" bIns="0" rtlCol="0" anchor="b"/>
-          <a:lstStyle/>
-          <a:p>
-            <a:pPr algn="l" indent="0" marL="0">
-              <a:buNone/>
-            </a:pPr>
-            <a:r>
-              <a:rPr lang="en-US" sz="1900" b="1" dirty="0">
-                <a:solidFill>
-                  <a:srgbClr val="1A1A2E"/>
-                </a:solidFill>
-                <a:latin typeface="Caveat" pitchFamily="34" charset="0"/>
-                <a:ea typeface="Caveat" pitchFamily="34" charset="-122"/>
-                <a:cs typeface="Caveat" pitchFamily="34" charset="-120"/>
-              </a:rPr>
-              <a:t>closer.</a:t>
-            </a:r>
-            <a:endParaRPr lang="en-US" sz="1900" dirty="0"/>
-          </a:p>
-        </p:txBody>
-      </p:sp>
-      <p:sp>
-        <p:nvSpPr>
-          <p:cNvPr id="41" name="Text 39"/>
-          <p:cNvSpPr/>
-          <p:nvPr/>
-        </p:nvSpPr>
-        <p:spPr>
-          <a:xfrm rot="-126000">
-            <a:off x="7974117" y="4273931"/>
-            <a:ext cx="868680" cy="374015"/>
-          </a:xfrm>
-          <a:prstGeom prst="rect">
-            <a:avLst/>
-          </a:prstGeom>
-          <a:noFill/>
-          <a:ln/>
-        </p:spPr>
-        <p:txBody>
-          <a:bodyPr wrap="square" lIns="0" tIns="0" rIns="0" bIns="0" rtlCol="0" anchor="b"/>
-          <a:lstStyle/>
-          <a:p>
-            <a:pPr algn="l" indent="0" marL="0">
-              <a:buNone/>
-            </a:pPr>
-            <a:r>
-              <a:rPr lang="en-US" sz="1900" b="1" dirty="0">
-                <a:solidFill>
-                  <a:srgbClr val="1A1A2E"/>
-                </a:solidFill>
-                <a:latin typeface="Caveat" pitchFamily="34" charset="0"/>
-                <a:ea typeface="Caveat" pitchFamily="34" charset="-122"/>
-                <a:cs typeface="Caveat" pitchFamily="34" charset="-120"/>
-              </a:rPr>
-              <a:t>That</a:t>
-            </a:r>
-            <a:endParaRPr lang="en-US" sz="1900" dirty="0"/>
-          </a:p>
-        </p:txBody>
-      </p:sp>
-      <p:sp>
-        <p:nvSpPr>
-          <p:cNvPr id="42" name="Text 40"/>
-          <p:cNvSpPr/>
-          <p:nvPr/>
-        </p:nvSpPr>
-        <p:spPr>
-          <a:xfrm rot="144000">
-            <a:off x="8714781" y="4243756"/>
-            <a:ext cx="1042416" cy="374015"/>
-          </a:xfrm>
-          <a:prstGeom prst="rect">
-            <a:avLst/>
-          </a:prstGeom>
-          <a:noFill/>
-          <a:ln/>
-        </p:spPr>
-        <p:txBody>
-          <a:bodyPr wrap="square" lIns="0" tIns="0" rIns="0" bIns="0" rtlCol="0" anchor="b"/>
-          <a:lstStyle/>
-          <a:p>
-            <a:pPr algn="l" indent="0" marL="0">
-              <a:buNone/>
-            </a:pPr>
-            <a:r>
-              <a:rPr lang="en-US" sz="1900" b="1" dirty="0">
-                <a:solidFill>
-                  <a:srgbClr val="1A1A2E"/>
-                </a:solidFill>
-                <a:latin typeface="Caveat" pitchFamily="34" charset="0"/>
-                <a:ea typeface="Caveat" pitchFamily="34" charset="-122"/>
-                <a:cs typeface="Caveat" pitchFamily="34" charset="-120"/>
-              </a:rPr>
-              <a:t>means</a:t>
-            </a:r>
-            <a:endParaRPr lang="en-US" sz="1900" dirty="0"/>
-          </a:p>
-        </p:txBody>
-      </p:sp>
-      <p:sp>
-        <p:nvSpPr>
-          <p:cNvPr id="43" name="Text 41"/>
-          <p:cNvSpPr/>
-          <p:nvPr/>
-        </p:nvSpPr>
-        <p:spPr>
-          <a:xfrm rot="-90000">
-            <a:off x="9629181" y="4282161"/>
-            <a:ext cx="868680" cy="374015"/>
-          </a:xfrm>
-          <a:prstGeom prst="rect">
-            <a:avLst/>
-          </a:prstGeom>
-          <a:noFill/>
-          <a:ln/>
-        </p:spPr>
-        <p:txBody>
-          <a:bodyPr wrap="square" lIns="0" tIns="0" rIns="0" bIns="0" rtlCol="0" anchor="b"/>
-          <a:lstStyle/>
-          <a:p>
-            <a:pPr algn="l" indent="0" marL="0">
-              <a:buNone/>
-            </a:pPr>
-            <a:r>
-              <a:rPr lang="en-US" sz="1900" b="1" dirty="0">
-                <a:solidFill>
-                  <a:srgbClr val="1A1A2E"/>
-                </a:solidFill>
-                <a:latin typeface="Caveat" pitchFamily="34" charset="0"/>
-                <a:ea typeface="Caveat" pitchFamily="34" charset="-122"/>
-                <a:cs typeface="Caveat" pitchFamily="34" charset="-120"/>
-              </a:rPr>
-              <a:t>more</a:t>
-            </a:r>
-            <a:endParaRPr lang="en-US" sz="1900" dirty="0"/>
-          </a:p>
-        </p:txBody>
-      </p:sp>
-      <p:sp>
-        <p:nvSpPr>
-          <p:cNvPr id="44" name="Text 42"/>
-          <p:cNvSpPr/>
-          <p:nvPr/>
-        </p:nvSpPr>
-        <p:spPr>
-          <a:xfrm rot="126000">
-            <a:off x="5404653" y="4623257"/>
-            <a:ext cx="1911096" cy="374015"/>
-          </a:xfrm>
-          <a:prstGeom prst="rect">
-            <a:avLst/>
-          </a:prstGeom>
-          <a:noFill/>
-          <a:ln/>
-        </p:spPr>
-        <p:txBody>
-          <a:bodyPr wrap="square" lIns="0" tIns="0" rIns="0" bIns="0" rtlCol="0" anchor="b"/>
-          <a:lstStyle/>
-          <a:p>
-            <a:pPr algn="l" indent="0" marL="0">
-              <a:buNone/>
-            </a:pPr>
-            <a:r>
-              <a:rPr lang="en-US" sz="1900" b="1" dirty="0">
-                <a:solidFill>
-                  <a:srgbClr val="1A1A2E"/>
-                </a:solidFill>
-                <a:latin typeface="Caveat" pitchFamily="34" charset="0"/>
-                <a:ea typeface="Caveat" pitchFamily="34" charset="-122"/>
-                <a:cs typeface="Caveat" pitchFamily="34" charset="-120"/>
-              </a:rPr>
-              <a:t>collisions</a:t>
-            </a:r>
-            <a:endParaRPr lang="en-US" sz="1900" dirty="0"/>
-          </a:p>
-        </p:txBody>
-      </p:sp>
-      <p:sp>
-        <p:nvSpPr>
-          <p:cNvPr id="45" name="Text 43"/>
-          <p:cNvSpPr/>
-          <p:nvPr/>
-        </p:nvSpPr>
-        <p:spPr>
-          <a:xfrm rot="-144000">
-            <a:off x="7187733" y="4653432"/>
-            <a:ext cx="521208" cy="374015"/>
-          </a:xfrm>
-          <a:prstGeom prst="rect">
-            <a:avLst/>
-          </a:prstGeom>
-          <a:noFill/>
-          <a:ln/>
-        </p:spPr>
-        <p:txBody>
-          <a:bodyPr wrap="square" lIns="0" tIns="0" rIns="0" bIns="0" rtlCol="0" anchor="b"/>
-          <a:lstStyle/>
-          <a:p>
-            <a:pPr algn="l" indent="0" marL="0">
-              <a:buNone/>
-            </a:pPr>
-            <a:r>
-              <a:rPr lang="en-US" sz="1900" b="1" dirty="0">
-                <a:solidFill>
-                  <a:srgbClr val="1A1A2E"/>
-                </a:solidFill>
-                <a:latin typeface="Caveat" pitchFamily="34" charset="0"/>
-                <a:ea typeface="Caveat" pitchFamily="34" charset="-122"/>
-                <a:cs typeface="Caveat" pitchFamily="34" charset="-120"/>
-              </a:rPr>
-              <a:t>so</a:t>
-            </a:r>
-            <a:endParaRPr lang="en-US" sz="1900" dirty="0"/>
-          </a:p>
-        </p:txBody>
-      </p:sp>
-      <p:sp>
-        <p:nvSpPr>
-          <p:cNvPr id="46" name="Text 44"/>
-          <p:cNvSpPr/>
-          <p:nvPr/>
-        </p:nvSpPr>
-        <p:spPr>
-          <a:xfrm rot="72000">
-            <a:off x="7580925" y="4620514"/>
-            <a:ext cx="694944" cy="374015"/>
-          </a:xfrm>
-          <a:prstGeom prst="rect">
-            <a:avLst/>
-          </a:prstGeom>
-          <a:noFill/>
-          <a:ln/>
-        </p:spPr>
-        <p:txBody>
-          <a:bodyPr wrap="square" lIns="0" tIns="0" rIns="0" bIns="0" rtlCol="0" anchor="b"/>
-          <a:lstStyle/>
-          <a:p>
-            <a:pPr algn="l" indent="0" marL="0">
-              <a:buNone/>
-            </a:pPr>
-            <a:r>
-              <a:rPr lang="en-US" sz="1900" b="1" dirty="0">
-                <a:solidFill>
-                  <a:srgbClr val="1A1A2E"/>
-                </a:solidFill>
-                <a:latin typeface="Caveat" pitchFamily="34" charset="0"/>
-                <a:ea typeface="Caveat" pitchFamily="34" charset="-122"/>
-                <a:cs typeface="Caveat" pitchFamily="34" charset="-120"/>
-              </a:rPr>
-              <a:t>the</a:t>
-            </a:r>
-            <a:endParaRPr lang="en-US" sz="1900" dirty="0"/>
-          </a:p>
-        </p:txBody>
-      </p:sp>
-      <p:sp>
-        <p:nvSpPr>
-          <p:cNvPr id="47" name="Text 45"/>
-          <p:cNvSpPr/>
-          <p:nvPr/>
-        </p:nvSpPr>
-        <p:spPr>
-          <a:xfrm rot="-162000">
-            <a:off x="8147853" y="4650689"/>
-            <a:ext cx="868680" cy="374015"/>
-          </a:xfrm>
-          <a:prstGeom prst="rect">
-            <a:avLst/>
-          </a:prstGeom>
-          <a:noFill/>
-          <a:ln/>
-        </p:spPr>
-        <p:txBody>
-          <a:bodyPr wrap="square" lIns="0" tIns="0" rIns="0" bIns="0" rtlCol="0" anchor="b"/>
-          <a:lstStyle/>
-          <a:p>
-            <a:pPr algn="l" indent="0" marL="0">
-              <a:buNone/>
-            </a:pPr>
-            <a:r>
-              <a:rPr lang="en-US" sz="1900" b="1" dirty="0">
-                <a:solidFill>
-                  <a:srgbClr val="1A1A2E"/>
-                </a:solidFill>
-                <a:latin typeface="Caveat" pitchFamily="34" charset="0"/>
-                <a:ea typeface="Caveat" pitchFamily="34" charset="-122"/>
-                <a:cs typeface="Caveat" pitchFamily="34" charset="-120"/>
-              </a:rPr>
-              <a:t>rate</a:t>
-            </a:r>
-            <a:endParaRPr lang="en-US" sz="1900" dirty="0"/>
-          </a:p>
-        </p:txBody>
-      </p:sp>
-      <p:sp>
-        <p:nvSpPr>
-          <p:cNvPr id="48" name="Text 46"/>
-          <p:cNvSpPr/>
-          <p:nvPr/>
-        </p:nvSpPr>
-        <p:spPr>
-          <a:xfrm rot="108000">
-            <a:off x="8888517" y="4615028"/>
-            <a:ext cx="868680" cy="374015"/>
-          </a:xfrm>
-          <a:prstGeom prst="rect">
-            <a:avLst/>
-          </a:prstGeom>
-          <a:noFill/>
-          <a:ln/>
-        </p:spPr>
-        <p:txBody>
-          <a:bodyPr wrap="square" lIns="0" tIns="0" rIns="0" bIns="0" rtlCol="0" anchor="b"/>
-          <a:lstStyle/>
-          <a:p>
-            <a:pPr algn="l" indent="0" marL="0">
-              <a:buNone/>
-            </a:pPr>
-            <a:r>
-              <a:rPr lang="en-US" sz="1900" b="1" dirty="0">
-                <a:solidFill>
-                  <a:srgbClr val="1A1A2E"/>
-                </a:solidFill>
-                <a:latin typeface="Caveat" pitchFamily="34" charset="0"/>
-                <a:ea typeface="Caveat" pitchFamily="34" charset="-122"/>
-                <a:cs typeface="Caveat" pitchFamily="34" charset="-120"/>
-              </a:rPr>
-              <a:t>goes</a:t>
-            </a:r>
-            <a:endParaRPr lang="en-US" sz="1900" dirty="0"/>
-          </a:p>
-        </p:txBody>
-      </p:sp>
-      <p:sp>
-        <p:nvSpPr>
-          <p:cNvPr id="49" name="Text 47"/>
-          <p:cNvSpPr/>
-          <p:nvPr/>
-        </p:nvSpPr>
-        <p:spPr>
-          <a:xfrm rot="-126000">
-            <a:off x="9629181" y="4647946"/>
-            <a:ext cx="694944" cy="374015"/>
-          </a:xfrm>
-          <a:prstGeom prst="rect">
-            <a:avLst/>
-          </a:prstGeom>
-          <a:noFill/>
-          <a:ln/>
-        </p:spPr>
-        <p:txBody>
-          <a:bodyPr wrap="square" lIns="0" tIns="0" rIns="0" bIns="0" rtlCol="0" anchor="b"/>
-          <a:lstStyle/>
-          <a:p>
-            <a:pPr algn="l" indent="0" marL="0">
-              <a:buNone/>
-            </a:pPr>
-            <a:r>
-              <a:rPr lang="en-US" sz="1900" b="1" dirty="0">
-                <a:solidFill>
-                  <a:srgbClr val="1A1A2E"/>
-                </a:solidFill>
-                <a:latin typeface="Caveat" pitchFamily="34" charset="0"/>
-                <a:ea typeface="Caveat" pitchFamily="34" charset="-122"/>
-                <a:cs typeface="Caveat" pitchFamily="34" charset="-120"/>
-              </a:rPr>
-              <a:t>up.</a:t>
-            </a:r>
-            <a:endParaRPr lang="en-US" sz="1900" dirty="0"/>
-          </a:p>
-        </p:txBody>
-      </p:sp>
-      <p:sp>
-        <p:nvSpPr>
           <p:cNvPr id="50" name="Shape 48"/>
           <p:cNvSpPr/>
           <p:nvPr/>
         </p:nvSpPr>
         <p:spPr>
           <a:xfrm>
-            <a:off x="5404653" y="4260215"/>
+            <a:off x="5404653" y="4855464"/>
             <a:ext cx="6199083" cy="0"/>
           </a:xfrm>
           <a:prstGeom prst="line">
@@ -17922,13 +17906,625 @@
       </p:sp>
       <p:sp>
         <p:nvSpPr>
-          <p:cNvPr id="51" name="Shape 49"/>
-          <p:cNvSpPr/>
-          <p:nvPr/>
-        </p:nvSpPr>
-        <p:spPr>
-          <a:xfrm>
-            <a:off x="5404653" y="4634230"/>
+          <p:cNvPr id="51" name="Text 49"/>
+          <p:cNvSpPr/>
+          <p:nvPr/>
+        </p:nvSpPr>
+        <p:spPr>
+          <a:xfrm>
+            <a:off x="5276637" y="5038344"/>
+            <a:ext cx="6500835" cy="237744"/>
+          </a:xfrm>
+          <a:prstGeom prst="rect">
+            <a:avLst/>
+          </a:prstGeom>
+          <a:solidFill>
+            <a:srgbClr val="0D1B5E"/>
+          </a:solidFill>
+          <a:ln/>
+        </p:spPr>
+        <p:txBody>
+          <a:bodyPr wrap="square" lIns="76200" tIns="76200" rIns="76200" bIns="76200" rtlCol="0" anchor="ctr"/>
+          <a:lstStyle/>
+          <a:p>
+            <a:pPr algn="l" indent="0" marL="0">
+              <a:buNone/>
+            </a:pPr>
+            <a:r>
+              <a:rPr lang="en-US" sz="1200" b="1" dirty="0">
+                <a:solidFill>
+                  <a:srgbClr val="FABB2E"/>
+                </a:solidFill>
+                <a:latin typeface="Trebuchet MS" pitchFamily="34" charset="0"/>
+                <a:ea typeface="Trebuchet MS" pitchFamily="34" charset="-122"/>
+                <a:cs typeface="Trebuchet MS" pitchFamily="34" charset="-120"/>
+              </a:rPr>
+              <a:t>Student C</a:t>
+            </a:r>
+            <a:endParaRPr lang="en-US" sz="1200" dirty="0"/>
+          </a:p>
+        </p:txBody>
+      </p:sp>
+      <p:sp>
+        <p:nvSpPr>
+          <p:cNvPr id="52" name="Shape 50"/>
+          <p:cNvSpPr/>
+          <p:nvPr/>
+        </p:nvSpPr>
+        <p:spPr>
+          <a:xfrm>
+            <a:off x="5276637" y="5276088"/>
+            <a:ext cx="6500835" cy="1188720"/>
+          </a:xfrm>
+          <a:prstGeom prst="rect">
+            <a:avLst/>
+          </a:prstGeom>
+          <a:solidFill>
+            <a:srgbClr val="FFFFFF"/>
+          </a:solidFill>
+          <a:ln w="25400">
+            <a:solidFill>
+              <a:srgbClr val="FABB2E"/>
+            </a:solidFill>
+            <a:prstDash val="solid"/>
+          </a:ln>
+        </p:spPr>
+      </p:sp>
+      <p:sp>
+        <p:nvSpPr>
+          <p:cNvPr id="53" name="Text 51"/>
+          <p:cNvSpPr/>
+          <p:nvPr/>
+        </p:nvSpPr>
+        <p:spPr>
+          <a:xfrm rot="-108000">
+            <a:off x="5404653" y="5396789"/>
+            <a:ext cx="515013" cy="484632"/>
+          </a:xfrm>
+          <a:prstGeom prst="rect">
+            <a:avLst/>
+          </a:prstGeom>
+          <a:noFill/>
+          <a:ln/>
+        </p:spPr>
+        <p:txBody>
+          <a:bodyPr wrap="square" lIns="0" tIns="0" rIns="0" bIns="0" rtlCol="0" anchor="b"/>
+          <a:lstStyle/>
+          <a:p>
+            <a:pPr algn="l" indent="0" marL="0">
+              <a:buNone/>
+            </a:pPr>
+            <a:r>
+              <a:rPr lang="en-US" sz="1900" b="1" dirty="0">
+                <a:solidFill>
+                  <a:srgbClr val="1A1A2E"/>
+                </a:solidFill>
+                <a:latin typeface="Caveat" pitchFamily="34" charset="0"/>
+                <a:ea typeface="Caveat" pitchFamily="34" charset="-122"/>
+                <a:cs typeface="Caveat" pitchFamily="34" charset="-120"/>
+              </a:rPr>
+              <a:t>The</a:t>
+            </a:r>
+            <a:endParaRPr lang="en-US" sz="1900" dirty="0"/>
+          </a:p>
+        </p:txBody>
+      </p:sp>
+      <p:sp>
+        <p:nvSpPr>
+          <p:cNvPr id="54" name="Text 52"/>
+          <p:cNvSpPr/>
+          <p:nvPr/>
+        </p:nvSpPr>
+        <p:spPr>
+          <a:xfrm rot="72000">
+            <a:off x="5791650" y="5372100"/>
+            <a:ext cx="918467" cy="484632"/>
+          </a:xfrm>
+          <a:prstGeom prst="rect">
+            <a:avLst/>
+          </a:prstGeom>
+          <a:noFill/>
+          <a:ln/>
+        </p:spPr>
+        <p:txBody>
+          <a:bodyPr wrap="square" lIns="0" tIns="0" rIns="0" bIns="0" rtlCol="0" anchor="b"/>
+          <a:lstStyle/>
+          <a:p>
+            <a:pPr algn="l" indent="0" marL="0">
+              <a:buNone/>
+            </a:pPr>
+            <a:r>
+              <a:rPr lang="en-US" sz="1900" b="1" dirty="0">
+                <a:solidFill>
+                  <a:srgbClr val="1A1A2E"/>
+                </a:solidFill>
+                <a:latin typeface="Caveat" pitchFamily="34" charset="0"/>
+                <a:ea typeface="Caveat" pitchFamily="34" charset="-122"/>
+                <a:cs typeface="Caveat" pitchFamily="34" charset="-120"/>
+              </a:rPr>
+              <a:t>particles</a:t>
+            </a:r>
+            <a:endParaRPr lang="en-US" sz="1900" dirty="0"/>
+          </a:p>
+        </p:txBody>
+      </p:sp>
+      <p:sp>
+        <p:nvSpPr>
+          <p:cNvPr id="55" name="Text 53"/>
+          <p:cNvSpPr/>
+          <p:nvPr/>
+        </p:nvSpPr>
+        <p:spPr>
+          <a:xfrm rot="-90000">
+            <a:off x="6582100" y="5394046"/>
+            <a:ext cx="591988" cy="484632"/>
+          </a:xfrm>
+          <a:prstGeom prst="rect">
+            <a:avLst/>
+          </a:prstGeom>
+          <a:noFill/>
+          <a:ln/>
+        </p:spPr>
+        <p:txBody>
+          <a:bodyPr wrap="square" lIns="0" tIns="0" rIns="0" bIns="0" rtlCol="0" anchor="b"/>
+          <a:lstStyle/>
+          <a:p>
+            <a:pPr algn="l" indent="0" marL="0">
+              <a:buNone/>
+            </a:pPr>
+            <a:r>
+              <a:rPr lang="en-US" sz="1900" b="1" dirty="0">
+                <a:solidFill>
+                  <a:srgbClr val="1A1A2E"/>
+                </a:solidFill>
+                <a:latin typeface="Caveat" pitchFamily="34" charset="0"/>
+                <a:ea typeface="Caveat" pitchFamily="34" charset="-122"/>
+                <a:cs typeface="Caveat" pitchFamily="34" charset="-120"/>
+              </a:rPr>
+              <a:t>have</a:t>
+            </a:r>
+            <a:endParaRPr lang="en-US" sz="1900" dirty="0"/>
+          </a:p>
+        </p:txBody>
+      </p:sp>
+      <p:sp>
+        <p:nvSpPr>
+          <p:cNvPr id="56" name="Text 54"/>
+          <p:cNvSpPr/>
+          <p:nvPr/>
+        </p:nvSpPr>
+        <p:spPr>
+          <a:xfrm rot="108000">
+            <a:off x="7046072" y="5374843"/>
+            <a:ext cx="601881" cy="484632"/>
+          </a:xfrm>
+          <a:prstGeom prst="rect">
+            <a:avLst/>
+          </a:prstGeom>
+          <a:noFill/>
+          <a:ln/>
+        </p:spPr>
+        <p:txBody>
+          <a:bodyPr wrap="square" lIns="0" tIns="0" rIns="0" bIns="0" rtlCol="0" anchor="b"/>
+          <a:lstStyle/>
+          <a:p>
+            <a:pPr algn="l" indent="0" marL="0">
+              <a:buNone/>
+            </a:pPr>
+            <a:r>
+              <a:rPr lang="en-US" sz="1900" b="1" dirty="0">
+                <a:solidFill>
+                  <a:srgbClr val="1A1A2E"/>
+                </a:solidFill>
+                <a:latin typeface="Caveat" pitchFamily="34" charset="0"/>
+                <a:ea typeface="Caveat" pitchFamily="34" charset="-122"/>
+                <a:cs typeface="Caveat" pitchFamily="34" charset="-120"/>
+              </a:rPr>
+              <a:t>more</a:t>
+            </a:r>
+            <a:endParaRPr lang="en-US" sz="1900" dirty="0"/>
+          </a:p>
+        </p:txBody>
+      </p:sp>
+      <p:sp>
+        <p:nvSpPr>
+          <p:cNvPr id="57" name="Text 55"/>
+          <p:cNvSpPr/>
+          <p:nvPr/>
+        </p:nvSpPr>
+        <p:spPr>
+          <a:xfrm rot="-54000">
+            <a:off x="7519937" y="5402275"/>
+            <a:ext cx="738698" cy="484632"/>
+          </a:xfrm>
+          <a:prstGeom prst="rect">
+            <a:avLst/>
+          </a:prstGeom>
+          <a:noFill/>
+          <a:ln/>
+        </p:spPr>
+        <p:txBody>
+          <a:bodyPr wrap="square" lIns="0" tIns="0" rIns="0" bIns="0" rtlCol="0" anchor="b"/>
+          <a:lstStyle/>
+          <a:p>
+            <a:pPr algn="l" indent="0" marL="0">
+              <a:buNone/>
+            </a:pPr>
+            <a:r>
+              <a:rPr lang="en-US" sz="1900" b="1" dirty="0">
+                <a:solidFill>
+                  <a:srgbClr val="1A1A2E"/>
+                </a:solidFill>
+                <a:latin typeface="Caveat" pitchFamily="34" charset="0"/>
+                <a:ea typeface="Caveat" pitchFamily="34" charset="-122"/>
+                <a:cs typeface="Caveat" pitchFamily="34" charset="-120"/>
+              </a:rPr>
+              <a:t>energy</a:t>
+            </a:r>
+            <a:endParaRPr lang="en-US" sz="1900" dirty="0"/>
+          </a:p>
+        </p:txBody>
+      </p:sp>
+      <p:sp>
+        <p:nvSpPr>
+          <p:cNvPr id="58" name="Text 56"/>
+          <p:cNvSpPr/>
+          <p:nvPr/>
+        </p:nvSpPr>
+        <p:spPr>
+          <a:xfrm rot="90000">
+            <a:off x="8130619" y="5377586"/>
+            <a:ext cx="381574" cy="484632"/>
+          </a:xfrm>
+          <a:prstGeom prst="rect">
+            <a:avLst/>
+          </a:prstGeom>
+          <a:noFill/>
+          <a:ln/>
+        </p:spPr>
+        <p:txBody>
+          <a:bodyPr wrap="square" lIns="0" tIns="0" rIns="0" bIns="0" rtlCol="0" anchor="b"/>
+          <a:lstStyle/>
+          <a:p>
+            <a:pPr algn="l" indent="0" marL="0">
+              <a:buNone/>
+            </a:pPr>
+            <a:r>
+              <a:rPr lang="en-US" sz="1900" b="1" dirty="0">
+                <a:solidFill>
+                  <a:srgbClr val="1A1A2E"/>
+                </a:solidFill>
+                <a:latin typeface="Caveat" pitchFamily="34" charset="0"/>
+                <a:ea typeface="Caveat" pitchFamily="34" charset="-122"/>
+                <a:cs typeface="Caveat" pitchFamily="34" charset="-120"/>
+              </a:rPr>
+              <a:t>so</a:t>
+            </a:r>
+            <a:endParaRPr lang="en-US" sz="1900" dirty="0"/>
+          </a:p>
+        </p:txBody>
+      </p:sp>
+      <p:sp>
+        <p:nvSpPr>
+          <p:cNvPr id="59" name="Text 57"/>
+          <p:cNvSpPr/>
+          <p:nvPr/>
+        </p:nvSpPr>
+        <p:spPr>
+          <a:xfrm rot="-36000">
+            <a:off x="8384177" y="5396789"/>
+            <a:ext cx="566651" cy="484632"/>
+          </a:xfrm>
+          <a:prstGeom prst="rect">
+            <a:avLst/>
+          </a:prstGeom>
+          <a:noFill/>
+          <a:ln/>
+        </p:spPr>
+        <p:txBody>
+          <a:bodyPr wrap="square" lIns="0" tIns="0" rIns="0" bIns="0" rtlCol="0" anchor="b"/>
+          <a:lstStyle/>
+          <a:p>
+            <a:pPr algn="l" indent="0" marL="0">
+              <a:buNone/>
+            </a:pPr>
+            <a:r>
+              <a:rPr lang="en-US" sz="1900" b="1" dirty="0">
+                <a:solidFill>
+                  <a:srgbClr val="1A1A2E"/>
+                </a:solidFill>
+                <a:latin typeface="Caveat" pitchFamily="34" charset="0"/>
+                <a:ea typeface="Caveat" pitchFamily="34" charset="-122"/>
+                <a:cs typeface="Caveat" pitchFamily="34" charset="-120"/>
+              </a:rPr>
+              <a:t>they</a:t>
+            </a:r>
+            <a:endParaRPr lang="en-US" sz="1900" dirty="0"/>
+          </a:p>
+        </p:txBody>
+      </p:sp>
+      <p:sp>
+        <p:nvSpPr>
+          <p:cNvPr id="60" name="Text 58"/>
+          <p:cNvSpPr/>
+          <p:nvPr/>
+        </p:nvSpPr>
+        <p:spPr>
+          <a:xfrm rot="-108000">
+            <a:off x="8822812" y="5396789"/>
+            <a:ext cx="451068" cy="484632"/>
+          </a:xfrm>
+          <a:prstGeom prst="rect">
+            <a:avLst/>
+          </a:prstGeom>
+          <a:noFill/>
+          <a:ln/>
+        </p:spPr>
+        <p:txBody>
+          <a:bodyPr wrap="square" lIns="0" tIns="0" rIns="0" bIns="0" rtlCol="0" anchor="b"/>
+          <a:lstStyle/>
+          <a:p>
+            <a:pPr algn="l" indent="0" marL="0">
+              <a:buNone/>
+            </a:pPr>
+            <a:r>
+              <a:rPr lang="en-US" sz="1900" b="1" dirty="0">
+                <a:solidFill>
+                  <a:srgbClr val="1A1A2E"/>
+                </a:solidFill>
+                <a:latin typeface="Caveat" pitchFamily="34" charset="0"/>
+                <a:ea typeface="Caveat" pitchFamily="34" charset="-122"/>
+                <a:cs typeface="Caveat" pitchFamily="34" charset="-120"/>
+              </a:rPr>
+              <a:t>hit</a:t>
+            </a:r>
+            <a:endParaRPr lang="en-US" sz="1900" dirty="0"/>
+          </a:p>
+        </p:txBody>
+      </p:sp>
+      <p:sp>
+        <p:nvSpPr>
+          <p:cNvPr id="61" name="Text 59"/>
+          <p:cNvSpPr/>
+          <p:nvPr/>
+        </p:nvSpPr>
+        <p:spPr>
+          <a:xfrm rot="72000">
+            <a:off x="9145864" y="5372100"/>
+            <a:ext cx="782856" cy="484632"/>
+          </a:xfrm>
+          <a:prstGeom prst="rect">
+            <a:avLst/>
+          </a:prstGeom>
+          <a:noFill/>
+          <a:ln/>
+        </p:spPr>
+        <p:txBody>
+          <a:bodyPr wrap="square" lIns="0" tIns="0" rIns="0" bIns="0" rtlCol="0" anchor="b"/>
+          <a:lstStyle/>
+          <a:p>
+            <a:pPr algn="l" indent="0" marL="0">
+              <a:buNone/>
+            </a:pPr>
+            <a:r>
+              <a:rPr lang="en-US" sz="1900" b="1" dirty="0">
+                <a:solidFill>
+                  <a:srgbClr val="1A1A2E"/>
+                </a:solidFill>
+                <a:latin typeface="Caveat" pitchFamily="34" charset="0"/>
+                <a:ea typeface="Caveat" pitchFamily="34" charset="-122"/>
+                <a:cs typeface="Caveat" pitchFamily="34" charset="-120"/>
+              </a:rPr>
+              <a:t>harder</a:t>
+            </a:r>
+            <a:endParaRPr lang="en-US" sz="1900" dirty="0"/>
+          </a:p>
+        </p:txBody>
+      </p:sp>
+      <p:sp>
+        <p:nvSpPr>
+          <p:cNvPr id="62" name="Text 60"/>
+          <p:cNvSpPr/>
+          <p:nvPr/>
+        </p:nvSpPr>
+        <p:spPr>
+          <a:xfrm rot="-90000">
+            <a:off x="9800704" y="5394046"/>
+            <a:ext cx="525148" cy="484632"/>
+          </a:xfrm>
+          <a:prstGeom prst="rect">
+            <a:avLst/>
+          </a:prstGeom>
+          <a:noFill/>
+          <a:ln/>
+        </p:spPr>
+        <p:txBody>
+          <a:bodyPr wrap="square" lIns="0" tIns="0" rIns="0" bIns="0" rtlCol="0" anchor="b"/>
+          <a:lstStyle/>
+          <a:p>
+            <a:pPr algn="l" indent="0" marL="0">
+              <a:buNone/>
+            </a:pPr>
+            <a:r>
+              <a:rPr lang="en-US" sz="1900" b="1" dirty="0">
+                <a:solidFill>
+                  <a:srgbClr val="1A1A2E"/>
+                </a:solidFill>
+                <a:latin typeface="Caveat" pitchFamily="34" charset="0"/>
+                <a:ea typeface="Caveat" pitchFamily="34" charset="-122"/>
+                <a:cs typeface="Caveat" pitchFamily="34" charset="-120"/>
+              </a:rPr>
+              <a:t>and</a:t>
+            </a:r>
+            <a:endParaRPr lang="en-US" sz="1900" dirty="0"/>
+          </a:p>
+        </p:txBody>
+      </p:sp>
+      <p:sp>
+        <p:nvSpPr>
+          <p:cNvPr id="63" name="Text 61"/>
+          <p:cNvSpPr/>
+          <p:nvPr/>
+        </p:nvSpPr>
+        <p:spPr>
+          <a:xfrm rot="108000">
+            <a:off x="10197836" y="5374843"/>
+            <a:ext cx="484368" cy="484632"/>
+          </a:xfrm>
+          <a:prstGeom prst="rect">
+            <a:avLst/>
+          </a:prstGeom>
+          <a:noFill/>
+          <a:ln/>
+        </p:spPr>
+        <p:txBody>
+          <a:bodyPr wrap="square" lIns="0" tIns="0" rIns="0" bIns="0" rtlCol="0" anchor="b"/>
+          <a:lstStyle/>
+          <a:p>
+            <a:pPr algn="l" indent="0" marL="0">
+              <a:buNone/>
+            </a:pPr>
+            <a:r>
+              <a:rPr lang="en-US" sz="1900" b="1" dirty="0">
+                <a:solidFill>
+                  <a:srgbClr val="1A1A2E"/>
+                </a:solidFill>
+                <a:latin typeface="Caveat" pitchFamily="34" charset="0"/>
+                <a:ea typeface="Caveat" pitchFamily="34" charset="-122"/>
+                <a:cs typeface="Caveat" pitchFamily="34" charset="-120"/>
+              </a:rPr>
+              <a:t>the</a:t>
+            </a:r>
+            <a:endParaRPr lang="en-US" sz="1900" dirty="0"/>
+          </a:p>
+        </p:txBody>
+      </p:sp>
+      <p:sp>
+        <p:nvSpPr>
+          <p:cNvPr id="64" name="Text 62"/>
+          <p:cNvSpPr/>
+          <p:nvPr/>
+        </p:nvSpPr>
+        <p:spPr>
+          <a:xfrm rot="-54000">
+            <a:off x="10554188" y="5402275"/>
+            <a:ext cx="897956" cy="484632"/>
+          </a:xfrm>
+          <a:prstGeom prst="rect">
+            <a:avLst/>
+          </a:prstGeom>
+          <a:noFill/>
+          <a:ln/>
+        </p:spPr>
+        <p:txBody>
+          <a:bodyPr wrap="square" lIns="0" tIns="0" rIns="0" bIns="0" rtlCol="0" anchor="b"/>
+          <a:lstStyle/>
+          <a:p>
+            <a:pPr algn="l" indent="0" marL="0">
+              <a:buNone/>
+            </a:pPr>
+            <a:r>
+              <a:rPr lang="en-US" sz="1900" b="1" dirty="0">
+                <a:solidFill>
+                  <a:srgbClr val="1A1A2E"/>
+                </a:solidFill>
+                <a:latin typeface="Caveat" pitchFamily="34" charset="0"/>
+                <a:ea typeface="Caveat" pitchFamily="34" charset="-122"/>
+                <a:cs typeface="Caveat" pitchFamily="34" charset="-120"/>
+              </a:rPr>
+              <a:t>reaction</a:t>
+            </a:r>
+            <a:endParaRPr lang="en-US" sz="1900" dirty="0"/>
+          </a:p>
+        </p:txBody>
+      </p:sp>
+      <p:sp>
+        <p:nvSpPr>
+          <p:cNvPr id="65" name="Text 63"/>
+          <p:cNvSpPr/>
+          <p:nvPr/>
+        </p:nvSpPr>
+        <p:spPr>
+          <a:xfrm rot="90000">
+            <a:off x="11324128" y="5377586"/>
+            <a:ext cx="341518" cy="484632"/>
+          </a:xfrm>
+          <a:prstGeom prst="rect">
+            <a:avLst/>
+          </a:prstGeom>
+          <a:noFill/>
+          <a:ln/>
+        </p:spPr>
+        <p:txBody>
+          <a:bodyPr wrap="square" lIns="0" tIns="0" rIns="0" bIns="0" rtlCol="0" anchor="b"/>
+          <a:lstStyle/>
+          <a:p>
+            <a:pPr algn="l" indent="0" marL="0">
+              <a:buNone/>
+            </a:pPr>
+            <a:r>
+              <a:rPr lang="en-US" sz="1900" b="1" dirty="0">
+                <a:solidFill>
+                  <a:srgbClr val="1A1A2E"/>
+                </a:solidFill>
+                <a:latin typeface="Caveat" pitchFamily="34" charset="0"/>
+                <a:ea typeface="Caveat" pitchFamily="34" charset="-122"/>
+                <a:cs typeface="Caveat" pitchFamily="34" charset="-120"/>
+              </a:rPr>
+              <a:t>is</a:t>
+            </a:r>
+            <a:endParaRPr lang="en-US" sz="1900" dirty="0"/>
+          </a:p>
+        </p:txBody>
+      </p:sp>
+      <p:sp>
+        <p:nvSpPr>
+          <p:cNvPr id="66" name="Text 64"/>
+          <p:cNvSpPr/>
+          <p:nvPr/>
+        </p:nvSpPr>
+        <p:spPr>
+          <a:xfrm rot="-36000">
+            <a:off x="5404653" y="5881421"/>
+            <a:ext cx="769343" cy="484632"/>
+          </a:xfrm>
+          <a:prstGeom prst="rect">
+            <a:avLst/>
+          </a:prstGeom>
+          <a:noFill/>
+          <a:ln/>
+        </p:spPr>
+        <p:txBody>
+          <a:bodyPr wrap="square" lIns="0" tIns="0" rIns="0" bIns="0" rtlCol="0" anchor="b"/>
+          <a:lstStyle/>
+          <a:p>
+            <a:pPr algn="l" indent="0" marL="0">
+              <a:buNone/>
+            </a:pPr>
+            <a:r>
+              <a:rPr lang="en-US" sz="1900" b="1" dirty="0">
+                <a:solidFill>
+                  <a:srgbClr val="1A1A2E"/>
+                </a:solidFill>
+                <a:latin typeface="Caveat" pitchFamily="34" charset="0"/>
+                <a:ea typeface="Caveat" pitchFamily="34" charset="-122"/>
+                <a:cs typeface="Caveat" pitchFamily="34" charset="-120"/>
+              </a:rPr>
+              <a:t>faster.</a:t>
+            </a:r>
+            <a:endParaRPr lang="en-US" sz="1900" dirty="0"/>
+          </a:p>
+        </p:txBody>
+      </p:sp>
+      <p:sp>
+        <p:nvSpPr>
+          <p:cNvPr id="67" name="Shape 65"/>
+          <p:cNvSpPr/>
+          <p:nvPr/>
+        </p:nvSpPr>
+        <p:spPr>
+          <a:xfrm>
+            <a:off x="5404653" y="5870448"/>
             <a:ext cx="6199083" cy="0"/>
           </a:xfrm>
           <a:prstGeom prst="line">
@@ -17945,625 +18541,13 @@
       </p:sp>
       <p:sp>
         <p:nvSpPr>
-          <p:cNvPr id="52" name="Text 50"/>
-          <p:cNvSpPr/>
-          <p:nvPr/>
-        </p:nvSpPr>
-        <p:spPr>
-          <a:xfrm>
-            <a:off x="5276637" y="5038344"/>
-            <a:ext cx="6500835" cy="237744"/>
-          </a:xfrm>
-          <a:prstGeom prst="rect">
-            <a:avLst/>
-          </a:prstGeom>
-          <a:solidFill>
-            <a:srgbClr val="0D1B5E"/>
-          </a:solidFill>
-          <a:ln/>
-        </p:spPr>
-        <p:txBody>
-          <a:bodyPr wrap="square" lIns="76200" tIns="76200" rIns="76200" bIns="76200" rtlCol="0" anchor="ctr"/>
-          <a:lstStyle/>
-          <a:p>
-            <a:pPr algn="l" indent="0" marL="0">
-              <a:buNone/>
-            </a:pPr>
-            <a:r>
-              <a:rPr lang="en-US" sz="1200" b="1" dirty="0">
-                <a:solidFill>
-                  <a:srgbClr val="FABB2E"/>
-                </a:solidFill>
-                <a:latin typeface="Trebuchet MS" pitchFamily="34" charset="0"/>
-                <a:ea typeface="Trebuchet MS" pitchFamily="34" charset="-122"/>
-                <a:cs typeface="Trebuchet MS" pitchFamily="34" charset="-120"/>
-              </a:rPr>
-              <a:t>Student C</a:t>
-            </a:r>
-            <a:endParaRPr lang="en-US" sz="1200" dirty="0"/>
-          </a:p>
-        </p:txBody>
-      </p:sp>
-      <p:sp>
-        <p:nvSpPr>
-          <p:cNvPr id="53" name="Shape 51"/>
-          <p:cNvSpPr/>
-          <p:nvPr/>
-        </p:nvSpPr>
-        <p:spPr>
-          <a:xfrm>
-            <a:off x="5276637" y="5276088"/>
-            <a:ext cx="6500835" cy="1188720"/>
-          </a:xfrm>
-          <a:prstGeom prst="rect">
-            <a:avLst/>
-          </a:prstGeom>
-          <a:solidFill>
-            <a:srgbClr val="FFFFFF"/>
-          </a:solidFill>
-          <a:ln w="25400">
-            <a:solidFill>
-              <a:srgbClr val="FABB2E"/>
-            </a:solidFill>
-            <a:prstDash val="solid"/>
-          </a:ln>
-        </p:spPr>
-      </p:sp>
-      <p:sp>
-        <p:nvSpPr>
-          <p:cNvPr id="54" name="Text 52"/>
-          <p:cNvSpPr/>
-          <p:nvPr/>
-        </p:nvSpPr>
-        <p:spPr>
-          <a:xfrm rot="-108000">
-            <a:off x="5404653" y="5396789"/>
-            <a:ext cx="694944" cy="484632"/>
-          </a:xfrm>
-          <a:prstGeom prst="rect">
-            <a:avLst/>
-          </a:prstGeom>
-          <a:noFill/>
-          <a:ln/>
-        </p:spPr>
-        <p:txBody>
-          <a:bodyPr wrap="square" lIns="0" tIns="0" rIns="0" bIns="0" rtlCol="0" anchor="b"/>
-          <a:lstStyle/>
-          <a:p>
-            <a:pPr algn="l" indent="0" marL="0">
-              <a:buNone/>
-            </a:pPr>
-            <a:r>
-              <a:rPr lang="en-US" sz="1900" b="1" dirty="0">
-                <a:solidFill>
-                  <a:srgbClr val="1A1A2E"/>
-                </a:solidFill>
-                <a:latin typeface="Caveat" pitchFamily="34" charset="0"/>
-                <a:ea typeface="Caveat" pitchFamily="34" charset="-122"/>
-                <a:cs typeface="Caveat" pitchFamily="34" charset="-120"/>
-              </a:rPr>
-              <a:t>The</a:t>
-            </a:r>
-            <a:endParaRPr lang="en-US" sz="1900" dirty="0"/>
-          </a:p>
-        </p:txBody>
-      </p:sp>
-      <p:sp>
-        <p:nvSpPr>
-          <p:cNvPr id="55" name="Text 53"/>
-          <p:cNvSpPr/>
-          <p:nvPr/>
-        </p:nvSpPr>
-        <p:spPr>
-          <a:xfrm rot="72000">
-            <a:off x="5971581" y="5372100"/>
-            <a:ext cx="1737360" cy="484632"/>
-          </a:xfrm>
-          <a:prstGeom prst="rect">
-            <a:avLst/>
-          </a:prstGeom>
-          <a:noFill/>
-          <a:ln/>
-        </p:spPr>
-        <p:txBody>
-          <a:bodyPr wrap="square" lIns="0" tIns="0" rIns="0" bIns="0" rtlCol="0" anchor="b"/>
-          <a:lstStyle/>
-          <a:p>
-            <a:pPr algn="l" indent="0" marL="0">
-              <a:buNone/>
-            </a:pPr>
-            <a:r>
-              <a:rPr lang="en-US" sz="1900" b="1" dirty="0">
-                <a:solidFill>
-                  <a:srgbClr val="1A1A2E"/>
-                </a:solidFill>
-                <a:latin typeface="Caveat" pitchFamily="34" charset="0"/>
-                <a:ea typeface="Caveat" pitchFamily="34" charset="-122"/>
-                <a:cs typeface="Caveat" pitchFamily="34" charset="-120"/>
-              </a:rPr>
-              <a:t>particles</a:t>
-            </a:r>
-            <a:endParaRPr lang="en-US" sz="1900" dirty="0"/>
-          </a:p>
-        </p:txBody>
-      </p:sp>
-      <p:sp>
-        <p:nvSpPr>
-          <p:cNvPr id="56" name="Text 54"/>
-          <p:cNvSpPr/>
-          <p:nvPr/>
-        </p:nvSpPr>
-        <p:spPr>
-          <a:xfrm rot="-90000">
-            <a:off x="7580925" y="5394046"/>
-            <a:ext cx="868680" cy="484632"/>
-          </a:xfrm>
-          <a:prstGeom prst="rect">
-            <a:avLst/>
-          </a:prstGeom>
-          <a:noFill/>
-          <a:ln/>
-        </p:spPr>
-        <p:txBody>
-          <a:bodyPr wrap="square" lIns="0" tIns="0" rIns="0" bIns="0" rtlCol="0" anchor="b"/>
-          <a:lstStyle/>
-          <a:p>
-            <a:pPr algn="l" indent="0" marL="0">
-              <a:buNone/>
-            </a:pPr>
-            <a:r>
-              <a:rPr lang="en-US" sz="1900" b="1" dirty="0">
-                <a:solidFill>
-                  <a:srgbClr val="1A1A2E"/>
-                </a:solidFill>
-                <a:latin typeface="Caveat" pitchFamily="34" charset="0"/>
-                <a:ea typeface="Caveat" pitchFamily="34" charset="-122"/>
-                <a:cs typeface="Caveat" pitchFamily="34" charset="-120"/>
-              </a:rPr>
-              <a:t>have</a:t>
-            </a:r>
-            <a:endParaRPr lang="en-US" sz="1900" dirty="0"/>
-          </a:p>
-        </p:txBody>
-      </p:sp>
-      <p:sp>
-        <p:nvSpPr>
-          <p:cNvPr id="57" name="Text 55"/>
-          <p:cNvSpPr/>
-          <p:nvPr/>
-        </p:nvSpPr>
-        <p:spPr>
-          <a:xfrm rot="108000">
-            <a:off x="8321589" y="5374843"/>
-            <a:ext cx="868680" cy="484632"/>
-          </a:xfrm>
-          <a:prstGeom prst="rect">
-            <a:avLst/>
-          </a:prstGeom>
-          <a:noFill/>
-          <a:ln/>
-        </p:spPr>
-        <p:txBody>
-          <a:bodyPr wrap="square" lIns="0" tIns="0" rIns="0" bIns="0" rtlCol="0" anchor="b"/>
-          <a:lstStyle/>
-          <a:p>
-            <a:pPr algn="l" indent="0" marL="0">
-              <a:buNone/>
-            </a:pPr>
-            <a:r>
-              <a:rPr lang="en-US" sz="1900" b="1" dirty="0">
-                <a:solidFill>
-                  <a:srgbClr val="1A1A2E"/>
-                </a:solidFill>
-                <a:latin typeface="Caveat" pitchFamily="34" charset="0"/>
-                <a:ea typeface="Caveat" pitchFamily="34" charset="-122"/>
-                <a:cs typeface="Caveat" pitchFamily="34" charset="-120"/>
-              </a:rPr>
-              <a:t>more</a:t>
-            </a:r>
-            <a:endParaRPr lang="en-US" sz="1900" dirty="0"/>
-          </a:p>
-        </p:txBody>
-      </p:sp>
-      <p:sp>
-        <p:nvSpPr>
-          <p:cNvPr id="58" name="Text 56"/>
-          <p:cNvSpPr/>
-          <p:nvPr/>
-        </p:nvSpPr>
-        <p:spPr>
-          <a:xfrm rot="-54000">
-            <a:off x="9062253" y="5402275"/>
-            <a:ext cx="1216152" cy="484632"/>
-          </a:xfrm>
-          <a:prstGeom prst="rect">
-            <a:avLst/>
-          </a:prstGeom>
-          <a:noFill/>
-          <a:ln/>
-        </p:spPr>
-        <p:txBody>
-          <a:bodyPr wrap="square" lIns="0" tIns="0" rIns="0" bIns="0" rtlCol="0" anchor="b"/>
-          <a:lstStyle/>
-          <a:p>
-            <a:pPr algn="l" indent="0" marL="0">
-              <a:buNone/>
-            </a:pPr>
-            <a:r>
-              <a:rPr lang="en-US" sz="1900" b="1" dirty="0">
-                <a:solidFill>
-                  <a:srgbClr val="1A1A2E"/>
-                </a:solidFill>
-                <a:latin typeface="Caveat" pitchFamily="34" charset="0"/>
-                <a:ea typeface="Caveat" pitchFamily="34" charset="-122"/>
-                <a:cs typeface="Caveat" pitchFamily="34" charset="-120"/>
-              </a:rPr>
-              <a:t>energy</a:t>
-            </a:r>
-            <a:endParaRPr lang="en-US" sz="1900" dirty="0"/>
-          </a:p>
-        </p:txBody>
-      </p:sp>
-      <p:sp>
-        <p:nvSpPr>
-          <p:cNvPr id="59" name="Text 57"/>
-          <p:cNvSpPr/>
-          <p:nvPr/>
-        </p:nvSpPr>
-        <p:spPr>
-          <a:xfrm rot="90000">
-            <a:off x="10150389" y="5377586"/>
-            <a:ext cx="521208" cy="484632"/>
-          </a:xfrm>
-          <a:prstGeom prst="rect">
-            <a:avLst/>
-          </a:prstGeom>
-          <a:noFill/>
-          <a:ln/>
-        </p:spPr>
-        <p:txBody>
-          <a:bodyPr wrap="square" lIns="0" tIns="0" rIns="0" bIns="0" rtlCol="0" anchor="b"/>
-          <a:lstStyle/>
-          <a:p>
-            <a:pPr algn="l" indent="0" marL="0">
-              <a:buNone/>
-            </a:pPr>
-            <a:r>
-              <a:rPr lang="en-US" sz="1900" b="1" dirty="0">
-                <a:solidFill>
-                  <a:srgbClr val="1A1A2E"/>
-                </a:solidFill>
-                <a:latin typeface="Caveat" pitchFamily="34" charset="0"/>
-                <a:ea typeface="Caveat" pitchFamily="34" charset="-122"/>
-                <a:cs typeface="Caveat" pitchFamily="34" charset="-120"/>
-              </a:rPr>
-              <a:t>so</a:t>
-            </a:r>
-            <a:endParaRPr lang="en-US" sz="1900" dirty="0"/>
-          </a:p>
-        </p:txBody>
-      </p:sp>
-      <p:sp>
-        <p:nvSpPr>
-          <p:cNvPr id="60" name="Text 58"/>
-          <p:cNvSpPr/>
-          <p:nvPr/>
-        </p:nvSpPr>
-        <p:spPr>
-          <a:xfrm rot="-36000">
-            <a:off x="10543581" y="5396789"/>
-            <a:ext cx="868680" cy="484632"/>
-          </a:xfrm>
-          <a:prstGeom prst="rect">
-            <a:avLst/>
-          </a:prstGeom>
-          <a:noFill/>
-          <a:ln/>
-        </p:spPr>
-        <p:txBody>
-          <a:bodyPr wrap="square" lIns="0" tIns="0" rIns="0" bIns="0" rtlCol="0" anchor="b"/>
-          <a:lstStyle/>
-          <a:p>
-            <a:pPr algn="l" indent="0" marL="0">
-              <a:buNone/>
-            </a:pPr>
-            <a:r>
-              <a:rPr lang="en-US" sz="1900" b="1" dirty="0">
-                <a:solidFill>
-                  <a:srgbClr val="1A1A2E"/>
-                </a:solidFill>
-                <a:latin typeface="Caveat" pitchFamily="34" charset="0"/>
-                <a:ea typeface="Caveat" pitchFamily="34" charset="-122"/>
-                <a:cs typeface="Caveat" pitchFamily="34" charset="-120"/>
-              </a:rPr>
-              <a:t>they</a:t>
-            </a:r>
-            <a:endParaRPr lang="en-US" sz="1900" dirty="0"/>
-          </a:p>
-        </p:txBody>
-      </p:sp>
-      <p:sp>
-        <p:nvSpPr>
-          <p:cNvPr id="61" name="Text 59"/>
-          <p:cNvSpPr/>
-          <p:nvPr/>
-        </p:nvSpPr>
-        <p:spPr>
-          <a:xfrm rot="-108000">
-            <a:off x="5404653" y="5881421"/>
-            <a:ext cx="694944" cy="484632"/>
-          </a:xfrm>
-          <a:prstGeom prst="rect">
-            <a:avLst/>
-          </a:prstGeom>
-          <a:noFill/>
-          <a:ln/>
-        </p:spPr>
-        <p:txBody>
-          <a:bodyPr wrap="square" lIns="0" tIns="0" rIns="0" bIns="0" rtlCol="0" anchor="b"/>
-          <a:lstStyle/>
-          <a:p>
-            <a:pPr algn="l" indent="0" marL="0">
-              <a:buNone/>
-            </a:pPr>
-            <a:r>
-              <a:rPr lang="en-US" sz="1900" b="1" dirty="0">
-                <a:solidFill>
-                  <a:srgbClr val="1A1A2E"/>
-                </a:solidFill>
-                <a:latin typeface="Caveat" pitchFamily="34" charset="0"/>
-                <a:ea typeface="Caveat" pitchFamily="34" charset="-122"/>
-                <a:cs typeface="Caveat" pitchFamily="34" charset="-120"/>
-              </a:rPr>
-              <a:t>hit</a:t>
-            </a:r>
-            <a:endParaRPr lang="en-US" sz="1900" dirty="0"/>
-          </a:p>
-        </p:txBody>
-      </p:sp>
-      <p:sp>
-        <p:nvSpPr>
-          <p:cNvPr id="62" name="Text 60"/>
-          <p:cNvSpPr/>
-          <p:nvPr/>
-        </p:nvSpPr>
-        <p:spPr>
-          <a:xfrm rot="72000">
-            <a:off x="5971581" y="5856732"/>
-            <a:ext cx="1216152" cy="484632"/>
-          </a:xfrm>
-          <a:prstGeom prst="rect">
-            <a:avLst/>
-          </a:prstGeom>
-          <a:noFill/>
-          <a:ln/>
-        </p:spPr>
-        <p:txBody>
-          <a:bodyPr wrap="square" lIns="0" tIns="0" rIns="0" bIns="0" rtlCol="0" anchor="b"/>
-          <a:lstStyle/>
-          <a:p>
-            <a:pPr algn="l" indent="0" marL="0">
-              <a:buNone/>
-            </a:pPr>
-            <a:r>
-              <a:rPr lang="en-US" sz="1900" b="1" dirty="0">
-                <a:solidFill>
-                  <a:srgbClr val="1A1A2E"/>
-                </a:solidFill>
-                <a:latin typeface="Caveat" pitchFamily="34" charset="0"/>
-                <a:ea typeface="Caveat" pitchFamily="34" charset="-122"/>
-                <a:cs typeface="Caveat" pitchFamily="34" charset="-120"/>
-              </a:rPr>
-              <a:t>harder</a:t>
-            </a:r>
-            <a:endParaRPr lang="en-US" sz="1900" dirty="0"/>
-          </a:p>
-        </p:txBody>
-      </p:sp>
-      <p:sp>
-        <p:nvSpPr>
-          <p:cNvPr id="63" name="Text 61"/>
-          <p:cNvSpPr/>
-          <p:nvPr/>
-        </p:nvSpPr>
-        <p:spPr>
-          <a:xfrm rot="-90000">
-            <a:off x="7059717" y="5878678"/>
-            <a:ext cx="694944" cy="484632"/>
-          </a:xfrm>
-          <a:prstGeom prst="rect">
-            <a:avLst/>
-          </a:prstGeom>
-          <a:noFill/>
-          <a:ln/>
-        </p:spPr>
-        <p:txBody>
-          <a:bodyPr wrap="square" lIns="0" tIns="0" rIns="0" bIns="0" rtlCol="0" anchor="b"/>
-          <a:lstStyle/>
-          <a:p>
-            <a:pPr algn="l" indent="0" marL="0">
-              <a:buNone/>
-            </a:pPr>
-            <a:r>
-              <a:rPr lang="en-US" sz="1900" b="1" dirty="0">
-                <a:solidFill>
-                  <a:srgbClr val="1A1A2E"/>
-                </a:solidFill>
-                <a:latin typeface="Caveat" pitchFamily="34" charset="0"/>
-                <a:ea typeface="Caveat" pitchFamily="34" charset="-122"/>
-                <a:cs typeface="Caveat" pitchFamily="34" charset="-120"/>
-              </a:rPr>
-              <a:t>and</a:t>
-            </a:r>
-            <a:endParaRPr lang="en-US" sz="1900" dirty="0"/>
-          </a:p>
-        </p:txBody>
-      </p:sp>
-      <p:sp>
-        <p:nvSpPr>
-          <p:cNvPr id="64" name="Text 62"/>
-          <p:cNvSpPr/>
-          <p:nvPr/>
-        </p:nvSpPr>
-        <p:spPr>
-          <a:xfrm rot="108000">
-            <a:off x="7626645" y="5859475"/>
-            <a:ext cx="694944" cy="484632"/>
-          </a:xfrm>
-          <a:prstGeom prst="rect">
-            <a:avLst/>
-          </a:prstGeom>
-          <a:noFill/>
-          <a:ln/>
-        </p:spPr>
-        <p:txBody>
-          <a:bodyPr wrap="square" lIns="0" tIns="0" rIns="0" bIns="0" rtlCol="0" anchor="b"/>
-          <a:lstStyle/>
-          <a:p>
-            <a:pPr algn="l" indent="0" marL="0">
-              <a:buNone/>
-            </a:pPr>
-            <a:r>
-              <a:rPr lang="en-US" sz="1900" b="1" dirty="0">
-                <a:solidFill>
-                  <a:srgbClr val="1A1A2E"/>
-                </a:solidFill>
-                <a:latin typeface="Caveat" pitchFamily="34" charset="0"/>
-                <a:ea typeface="Caveat" pitchFamily="34" charset="-122"/>
-                <a:cs typeface="Caveat" pitchFamily="34" charset="-120"/>
-              </a:rPr>
-              <a:t>the</a:t>
-            </a:r>
-            <a:endParaRPr lang="en-US" sz="1900" dirty="0"/>
-          </a:p>
-        </p:txBody>
-      </p:sp>
-      <p:sp>
-        <p:nvSpPr>
-          <p:cNvPr id="65" name="Text 63"/>
-          <p:cNvSpPr/>
-          <p:nvPr/>
-        </p:nvSpPr>
-        <p:spPr>
-          <a:xfrm rot="-54000">
-            <a:off x="8193573" y="5886907"/>
-            <a:ext cx="1563624" cy="484632"/>
-          </a:xfrm>
-          <a:prstGeom prst="rect">
-            <a:avLst/>
-          </a:prstGeom>
-          <a:noFill/>
-          <a:ln/>
-        </p:spPr>
-        <p:txBody>
-          <a:bodyPr wrap="square" lIns="0" tIns="0" rIns="0" bIns="0" rtlCol="0" anchor="b"/>
-          <a:lstStyle/>
-          <a:p>
-            <a:pPr algn="l" indent="0" marL="0">
-              <a:buNone/>
-            </a:pPr>
-            <a:r>
-              <a:rPr lang="en-US" sz="1900" b="1" dirty="0">
-                <a:solidFill>
-                  <a:srgbClr val="1A1A2E"/>
-                </a:solidFill>
-                <a:latin typeface="Caveat" pitchFamily="34" charset="0"/>
-                <a:ea typeface="Caveat" pitchFamily="34" charset="-122"/>
-                <a:cs typeface="Caveat" pitchFamily="34" charset="-120"/>
-              </a:rPr>
-              <a:t>reaction</a:t>
-            </a:r>
-            <a:endParaRPr lang="en-US" sz="1900" dirty="0"/>
-          </a:p>
-        </p:txBody>
-      </p:sp>
-      <p:sp>
-        <p:nvSpPr>
-          <p:cNvPr id="66" name="Text 64"/>
-          <p:cNvSpPr/>
-          <p:nvPr/>
-        </p:nvSpPr>
-        <p:spPr>
-          <a:xfrm rot="90000">
-            <a:off x="9629181" y="5862218"/>
-            <a:ext cx="521208" cy="484632"/>
-          </a:xfrm>
-          <a:prstGeom prst="rect">
-            <a:avLst/>
-          </a:prstGeom>
-          <a:noFill/>
-          <a:ln/>
-        </p:spPr>
-        <p:txBody>
-          <a:bodyPr wrap="square" lIns="0" tIns="0" rIns="0" bIns="0" rtlCol="0" anchor="b"/>
-          <a:lstStyle/>
-          <a:p>
-            <a:pPr algn="l" indent="0" marL="0">
-              <a:buNone/>
-            </a:pPr>
-            <a:r>
-              <a:rPr lang="en-US" sz="1900" b="1" dirty="0">
-                <a:solidFill>
-                  <a:srgbClr val="1A1A2E"/>
-                </a:solidFill>
-                <a:latin typeface="Caveat" pitchFamily="34" charset="0"/>
-                <a:ea typeface="Caveat" pitchFamily="34" charset="-122"/>
-                <a:cs typeface="Caveat" pitchFamily="34" charset="-120"/>
-              </a:rPr>
-              <a:t>is</a:t>
-            </a:r>
-            <a:endParaRPr lang="en-US" sz="1900" dirty="0"/>
-          </a:p>
-        </p:txBody>
-      </p:sp>
-      <p:sp>
-        <p:nvSpPr>
-          <p:cNvPr id="67" name="Text 65"/>
-          <p:cNvSpPr/>
-          <p:nvPr/>
-        </p:nvSpPr>
-        <p:spPr>
-          <a:xfrm rot="-36000">
-            <a:off x="10022373" y="5881421"/>
-            <a:ext cx="1389888" cy="484632"/>
-          </a:xfrm>
-          <a:prstGeom prst="rect">
-            <a:avLst/>
-          </a:prstGeom>
-          <a:noFill/>
-          <a:ln/>
-        </p:spPr>
-        <p:txBody>
-          <a:bodyPr wrap="square" lIns="0" tIns="0" rIns="0" bIns="0" rtlCol="0" anchor="b"/>
-          <a:lstStyle/>
-          <a:p>
-            <a:pPr algn="l" indent="0" marL="0">
-              <a:buNone/>
-            </a:pPr>
-            <a:r>
-              <a:rPr lang="en-US" sz="1900" b="1" dirty="0">
-                <a:solidFill>
-                  <a:srgbClr val="1A1A2E"/>
-                </a:solidFill>
-                <a:latin typeface="Caveat" pitchFamily="34" charset="0"/>
-                <a:ea typeface="Caveat" pitchFamily="34" charset="-122"/>
-                <a:cs typeface="Caveat" pitchFamily="34" charset="-120"/>
-              </a:rPr>
-              <a:t>faster.</a:t>
-            </a:r>
-            <a:endParaRPr lang="en-US" sz="1900" dirty="0"/>
-          </a:p>
-        </p:txBody>
-      </p:sp>
-      <p:sp>
-        <p:nvSpPr>
           <p:cNvPr id="68" name="Shape 66"/>
           <p:cNvSpPr/>
           <p:nvPr/>
         </p:nvSpPr>
         <p:spPr>
           <a:xfrm>
-            <a:off x="5404653" y="5870448"/>
+            <a:off x="5404653" y="6355080"/>
             <a:ext cx="6199083" cy="0"/>
           </a:xfrm>
           <a:prstGeom prst="line">
@@ -18580,30 +18564,7 @@
       </p:sp>
       <p:sp>
         <p:nvSpPr>
-          <p:cNvPr id="69" name="Shape 67"/>
-          <p:cNvSpPr/>
-          <p:nvPr/>
-        </p:nvSpPr>
-        <p:spPr>
-          <a:xfrm>
-            <a:off x="5404653" y="6355080"/>
-            <a:ext cx="6199083" cy="0"/>
-          </a:xfrm>
-          <a:prstGeom prst="line">
-            <a:avLst/>
-          </a:prstGeom>
-          <a:noFill/>
-          <a:ln w="9525">
-            <a:solidFill>
-              <a:srgbClr val="C9C9DC"/>
-            </a:solidFill>
-            <a:prstDash val="solid"/>
-          </a:ln>
-        </p:spPr>
-      </p:sp>
-      <p:sp>
-        <p:nvSpPr>
-          <p:cNvPr id="70" name="Text 68"/>
+          <p:cNvPr id="69" name="Text 67"/>
           <p:cNvSpPr/>
           <p:nvPr/>
         </p:nvSpPr>
@@ -20571,8 +20532,8 @@
         </p:nvSpPr>
         <p:spPr>
           <a:xfrm rot="-162000">
-            <a:off x="539496" y="1598371"/>
-            <a:ext cx="374904" cy="527426"/>
+            <a:off x="539496" y="1909262"/>
+            <a:ext cx="365450" cy="433070"/>
           </a:xfrm>
           <a:prstGeom prst="rect">
             <a:avLst/>
@@ -20610,8 +20571,8 @@
         </p:nvSpPr>
         <p:spPr>
           <a:xfrm rot="108000">
-            <a:off x="786384" y="1562710"/>
-            <a:ext cx="1783080" cy="527426"/>
+            <a:off x="776930" y="1873601"/>
+            <a:ext cx="1001365" cy="433070"/>
           </a:xfrm>
           <a:prstGeom prst="rect">
             <a:avLst/>
@@ -20649,8 +20610,8 @@
         </p:nvSpPr>
         <p:spPr>
           <a:xfrm rot="-126000">
-            <a:off x="2441448" y="1595628"/>
-            <a:ext cx="576072" cy="527426"/>
+            <a:off x="1650279" y="1906519"/>
+            <a:ext cx="375229" cy="433070"/>
           </a:xfrm>
           <a:prstGeom prst="rect">
             <a:avLst/>
@@ -20688,8 +20649,8 @@
         </p:nvSpPr>
         <p:spPr>
           <a:xfrm rot="144000">
-            <a:off x="2889504" y="1565453"/>
-            <a:ext cx="978408" cy="527426"/>
+            <a:off x="1897492" y="1876344"/>
+            <a:ext cx="629483" cy="433070"/>
           </a:xfrm>
           <a:prstGeom prst="rect">
             <a:avLst/>
@@ -20727,8 +20688,8 @@
         </p:nvSpPr>
         <p:spPr>
           <a:xfrm rot="-90000">
-            <a:off x="3739896" y="1603858"/>
-            <a:ext cx="576072" cy="527426"/>
+            <a:off x="2398959" y="1914749"/>
+            <a:ext cx="431668" cy="433070"/>
           </a:xfrm>
           <a:prstGeom prst="rect">
             <a:avLst/>
@@ -20766,8 +20727,8 @@
         </p:nvSpPr>
         <p:spPr>
           <a:xfrm rot="126000">
-            <a:off x="4187952" y="1570939"/>
-            <a:ext cx="576072" cy="527426"/>
+            <a:off x="2702611" y="1881830"/>
+            <a:ext cx="405684" cy="433070"/>
           </a:xfrm>
           <a:prstGeom prst="rect">
             <a:avLst/>
@@ -20805,8 +20766,8 @@
         </p:nvSpPr>
         <p:spPr>
           <a:xfrm rot="-144000">
-            <a:off x="4636008" y="1601114"/>
-            <a:ext cx="777240" cy="527426"/>
+            <a:off x="2980279" y="1912005"/>
+            <a:ext cx="540634" cy="433070"/>
           </a:xfrm>
           <a:prstGeom prst="rect">
             <a:avLst/>
@@ -20844,8 +20805,8 @@
         </p:nvSpPr>
         <p:spPr>
           <a:xfrm rot="72000">
-            <a:off x="539496" y="2095622"/>
-            <a:ext cx="1984248" cy="527426"/>
+            <a:off x="3392896" y="1879087"/>
+            <a:ext cx="1074847" cy="433070"/>
           </a:xfrm>
           <a:prstGeom prst="rect">
             <a:avLst/>
@@ -20969,8 +20930,8 @@
         </p:nvSpPr>
         <p:spPr>
           <a:xfrm rot="-162000">
-            <a:off x="6268212" y="1598371"/>
-            <a:ext cx="1380744" cy="527426"/>
+            <a:off x="6268212" y="1909262"/>
+            <a:ext cx="905251" cy="433070"/>
           </a:xfrm>
           <a:prstGeom prst="rect">
             <a:avLst/>
@@ -21008,8 +20969,8 @@
         </p:nvSpPr>
         <p:spPr>
           <a:xfrm rot="108000">
-            <a:off x="7520940" y="1562710"/>
-            <a:ext cx="1783080" cy="527426"/>
+            <a:off x="7045447" y="1873601"/>
+            <a:ext cx="1038525" cy="433070"/>
           </a:xfrm>
           <a:prstGeom prst="rect">
             <a:avLst/>
@@ -21047,8 +21008,8 @@
         </p:nvSpPr>
         <p:spPr>
           <a:xfrm rot="-126000">
-            <a:off x="9176004" y="1595628"/>
-            <a:ext cx="978408" cy="527426"/>
+            <a:off x="7955956" y="1906519"/>
+            <a:ext cx="676702" cy="433070"/>
           </a:xfrm>
           <a:prstGeom prst="rect">
             <a:avLst/>
@@ -21086,8 +21047,8 @@
         </p:nvSpPr>
         <p:spPr>
           <a:xfrm rot="144000">
-            <a:off x="10026396" y="1565453"/>
-            <a:ext cx="777240" cy="527426"/>
+            <a:off x="8504641" y="1876344"/>
+            <a:ext cx="546781" cy="433070"/>
           </a:xfrm>
           <a:prstGeom prst="rect">
             <a:avLst/>
@@ -21125,8 +21086,8 @@
         </p:nvSpPr>
         <p:spPr>
           <a:xfrm rot="-90000">
-            <a:off x="10675620" y="1603858"/>
-            <a:ext cx="978408" cy="527426"/>
+            <a:off x="8923406" y="1914749"/>
+            <a:ext cx="700171" cy="433070"/>
           </a:xfrm>
           <a:prstGeom prst="rect">
             <a:avLst/>
@@ -21164,8 +21125,8 @@
         </p:nvSpPr>
         <p:spPr>
           <a:xfrm rot="126000">
-            <a:off x="6268212" y="2098365"/>
-            <a:ext cx="1380744" cy="527426"/>
+            <a:off x="9495561" y="1881830"/>
+            <a:ext cx="770021" cy="433070"/>
           </a:xfrm>
           <a:prstGeom prst="rect">
             <a:avLst/>
@@ -21289,8 +21250,8 @@
         </p:nvSpPr>
         <p:spPr>
           <a:xfrm rot="-162000">
-            <a:off x="539496" y="4140403"/>
-            <a:ext cx="1380744" cy="527426"/>
+            <a:off x="539496" y="4451294"/>
+            <a:ext cx="865576" cy="433070"/>
           </a:xfrm>
           <a:prstGeom prst="rect">
             <a:avLst/>
@@ -21328,8 +21289,8 @@
         </p:nvSpPr>
         <p:spPr>
           <a:xfrm rot="108000">
-            <a:off x="1792224" y="4104742"/>
-            <a:ext cx="2788920" cy="527426"/>
+            <a:off x="1277056" y="4415633"/>
+            <a:ext cx="1571341" cy="433070"/>
           </a:xfrm>
           <a:prstGeom prst="rect">
             <a:avLst/>
@@ -21367,8 +21328,8 @@
         </p:nvSpPr>
         <p:spPr>
           <a:xfrm rot="-126000">
-            <a:off x="4453128" y="4137660"/>
-            <a:ext cx="1179576" cy="527426"/>
+            <a:off x="2720381" y="4448551"/>
+            <a:ext cx="662732" cy="433070"/>
           </a:xfrm>
           <a:prstGeom prst="rect">
             <a:avLst/>
@@ -21406,8 +21367,8 @@
         </p:nvSpPr>
         <p:spPr>
           <a:xfrm rot="144000">
-            <a:off x="539496" y="4634911"/>
-            <a:ext cx="1984248" cy="527426"/>
+            <a:off x="3255096" y="4418376"/>
+            <a:ext cx="1043275" cy="433070"/>
           </a:xfrm>
           <a:prstGeom prst="rect">
             <a:avLst/>
@@ -21445,8 +21406,8 @@
         </p:nvSpPr>
         <p:spPr>
           <a:xfrm rot="-90000">
-            <a:off x="2395728" y="4673316"/>
-            <a:ext cx="978408" cy="527426"/>
+            <a:off x="4170355" y="4456781"/>
+            <a:ext cx="676702" cy="433070"/>
           </a:xfrm>
           <a:prstGeom prst="rect">
             <a:avLst/>
@@ -21484,8 +21445,8 @@
         </p:nvSpPr>
         <p:spPr>
           <a:xfrm rot="126000">
-            <a:off x="3246120" y="4640397"/>
-            <a:ext cx="1581912" cy="527426"/>
+            <a:off x="4719041" y="4423862"/>
+            <a:ext cx="890443" cy="433070"/>
           </a:xfrm>
           <a:prstGeom prst="rect">
             <a:avLst/>
@@ -21609,8 +21570,8 @@
         </p:nvSpPr>
         <p:spPr>
           <a:xfrm rot="-162000">
-            <a:off x="6268212" y="4140403"/>
-            <a:ext cx="777240" cy="527426"/>
+            <a:off x="6268212" y="4451294"/>
+            <a:ext cx="576118" cy="433070"/>
           </a:xfrm>
           <a:prstGeom prst="rect">
             <a:avLst/>
@@ -21648,8 +21609,8 @@
         </p:nvSpPr>
         <p:spPr>
           <a:xfrm rot="108000">
-            <a:off x="6917436" y="4104742"/>
-            <a:ext cx="978408" cy="527426"/>
+            <a:off x="6716314" y="4415633"/>
+            <a:ext cx="633674" cy="433070"/>
           </a:xfrm>
           <a:prstGeom prst="rect">
             <a:avLst/>
@@ -21687,8 +21648,8 @@
         </p:nvSpPr>
         <p:spPr>
           <a:xfrm rot="-126000">
-            <a:off x="7767828" y="4137660"/>
-            <a:ext cx="576072" cy="527426"/>
+            <a:off x="7221972" y="4448551"/>
+            <a:ext cx="375229" cy="433070"/>
           </a:xfrm>
           <a:prstGeom prst="rect">
             <a:avLst/>
@@ -21726,8 +21687,8 @@
         </p:nvSpPr>
         <p:spPr>
           <a:xfrm rot="144000">
-            <a:off x="8215884" y="4107485"/>
-            <a:ext cx="1581912" cy="527426"/>
+            <a:off x="7469185" y="4418376"/>
+            <a:ext cx="927044" cy="433070"/>
           </a:xfrm>
           <a:prstGeom prst="rect">
             <a:avLst/>
@@ -21765,8 +21726,8 @@
         </p:nvSpPr>
         <p:spPr>
           <a:xfrm rot="-90000">
-            <a:off x="9669780" y="4145890"/>
-            <a:ext cx="978408" cy="527426"/>
+            <a:off x="8268213" y="4456781"/>
+            <a:ext cx="720847" cy="433070"/>
           </a:xfrm>
           <a:prstGeom prst="rect">
             <a:avLst/>
@@ -21804,8 +21765,8 @@
         </p:nvSpPr>
         <p:spPr>
           <a:xfrm rot="126000">
-            <a:off x="10520172" y="4112971"/>
-            <a:ext cx="777240" cy="527426"/>
+            <a:off x="8861044" y="4423862"/>
+            <a:ext cx="540634" cy="433070"/>
           </a:xfrm>
           <a:prstGeom prst="rect">
             <a:avLst/>
@@ -21843,8 +21804,8 @@
         </p:nvSpPr>
         <p:spPr>
           <a:xfrm rot="-144000">
-            <a:off x="6268212" y="4670572"/>
-            <a:ext cx="1179576" cy="527426"/>
+            <a:off x="9273662" y="4454037"/>
+            <a:ext cx="787344" cy="433070"/>
           </a:xfrm>
           <a:prstGeom prst="rect">
             <a:avLst/>
@@ -21882,8 +21843,8 @@
         </p:nvSpPr>
         <p:spPr>
           <a:xfrm rot="72000">
-            <a:off x="7319772" y="4637654"/>
-            <a:ext cx="576072" cy="527426"/>
+            <a:off x="9932990" y="4421119"/>
+            <a:ext cx="375229" cy="433070"/>
           </a:xfrm>
           <a:prstGeom prst="rect">
             <a:avLst/>
@@ -21921,8 +21882,8 @@
         </p:nvSpPr>
         <p:spPr>
           <a:xfrm rot="-162000">
-            <a:off x="7767828" y="4667829"/>
-            <a:ext cx="1179576" cy="527426"/>
+            <a:off x="10180203" y="4451294"/>
+            <a:ext cx="628645" cy="433070"/>
           </a:xfrm>
           <a:prstGeom prst="rect">
             <a:avLst/>

</xml_diff>